<commit_message>
Adapt Casablanca workshop to story-run-review format
</commit_message>
<xml_diff>
--- a/workshop/slides/atelier-pdsf-pdo-casablanca.pptx
+++ b/workshop/slides/atelier-pdsf-pdo-casablanca.pptx
@@ -2,25 +2,25 @@
 <file path=ppt/presentation.xml><?xml version="1.0" encoding="utf-8"?>
 <p:presentation xmlns:p="http://schemas.openxmlformats.org/presentationml/2006/main">
   <p:sldMasterIdLst>
-    <p:sldMasterId xmlns:r="http://schemas.openxmlformats.org/officeDocument/2006/relationships" id="2147483648" r:id="R72b921c8784a44a0"/>
+    <p:sldMasterId xmlns:r="http://schemas.openxmlformats.org/officeDocument/2006/relationships" id="2147483648" r:id="R7e69c6f197214aad"/>
   </p:sldMasterIdLst>
   <p:notesMasterIdLst>
-    <p:notesMasterId xmlns:r="http://schemas.openxmlformats.org/officeDocument/2006/relationships" r:id="R0a8c2f6140824b5e"/>
+    <p:notesMasterId xmlns:r="http://schemas.openxmlformats.org/officeDocument/2006/relationships" r:id="R57cbfc53ea5f48c9"/>
   </p:notesMasterIdLst>
   <p:sldIdLst>
-    <p:sldId xmlns:r="http://schemas.openxmlformats.org/officeDocument/2006/relationships" id="256" r:id="R3955c8ab7e5a4168"/>
-    <p:sldId xmlns:r="http://schemas.openxmlformats.org/officeDocument/2006/relationships" id="257" r:id="R77fac3df20544efe"/>
-    <p:sldId xmlns:r="http://schemas.openxmlformats.org/officeDocument/2006/relationships" id="258" r:id="R61b9d3733b3d4c7c"/>
-    <p:sldId xmlns:r="http://schemas.openxmlformats.org/officeDocument/2006/relationships" id="259" r:id="R4eb89c0d96534f49"/>
-    <p:sldId xmlns:r="http://schemas.openxmlformats.org/officeDocument/2006/relationships" id="260" r:id="R8c76944ee5774657"/>
-    <p:sldId xmlns:r="http://schemas.openxmlformats.org/officeDocument/2006/relationships" id="261" r:id="R49d6fa3f5e9a4be4"/>
-    <p:sldId xmlns:r="http://schemas.openxmlformats.org/officeDocument/2006/relationships" id="262" r:id="Rb3c21038dcd14a09"/>
-    <p:sldId xmlns:r="http://schemas.openxmlformats.org/officeDocument/2006/relationships" id="263" r:id="Rd2d3d1f08df649b9"/>
-    <p:sldId xmlns:r="http://schemas.openxmlformats.org/officeDocument/2006/relationships" id="264" r:id="R01bfaae596d04ea0"/>
-    <p:sldId xmlns:r="http://schemas.openxmlformats.org/officeDocument/2006/relationships" id="265" r:id="R9a0e9da2b7234356"/>
-    <p:sldId xmlns:r="http://schemas.openxmlformats.org/officeDocument/2006/relationships" id="266" r:id="Rd4ddeb63beb644ac"/>
-    <p:sldId xmlns:r="http://schemas.openxmlformats.org/officeDocument/2006/relationships" id="267" r:id="Rd01208b1ca9c4b43"/>
-    <p:sldId xmlns:r="http://schemas.openxmlformats.org/officeDocument/2006/relationships" id="268" r:id="Rcff05c5e11974098"/>
+    <p:sldId xmlns:r="http://schemas.openxmlformats.org/officeDocument/2006/relationships" id="256" r:id="Rd2f3da2c80164c85"/>
+    <p:sldId xmlns:r="http://schemas.openxmlformats.org/officeDocument/2006/relationships" id="257" r:id="R09ec743ddfd743fe"/>
+    <p:sldId xmlns:r="http://schemas.openxmlformats.org/officeDocument/2006/relationships" id="258" r:id="R9a45c6725a044770"/>
+    <p:sldId xmlns:r="http://schemas.openxmlformats.org/officeDocument/2006/relationships" id="259" r:id="Re97f70282f1649c4"/>
+    <p:sldId xmlns:r="http://schemas.openxmlformats.org/officeDocument/2006/relationships" id="260" r:id="Ra2e20cb5b45c4ce2"/>
+    <p:sldId xmlns:r="http://schemas.openxmlformats.org/officeDocument/2006/relationships" id="261" r:id="Rdbfa7393240d4621"/>
+    <p:sldId xmlns:r="http://schemas.openxmlformats.org/officeDocument/2006/relationships" id="262" r:id="R186eb349000f4b4c"/>
+    <p:sldId xmlns:r="http://schemas.openxmlformats.org/officeDocument/2006/relationships" id="263" r:id="Rc0a0479f8f984ab3"/>
+    <p:sldId xmlns:r="http://schemas.openxmlformats.org/officeDocument/2006/relationships" id="264" r:id="Rae344f0688224ec9"/>
+    <p:sldId xmlns:r="http://schemas.openxmlformats.org/officeDocument/2006/relationships" id="265" r:id="R06d84025079d4d58"/>
+    <p:sldId xmlns:r="http://schemas.openxmlformats.org/officeDocument/2006/relationships" id="266" r:id="Rf4bbdaabb6984351"/>
+    <p:sldId xmlns:r="http://schemas.openxmlformats.org/officeDocument/2006/relationships" id="267" r:id="R6b977e9aa2914714"/>
+    <p:sldId xmlns:r="http://schemas.openxmlformats.org/officeDocument/2006/relationships" id="268" r:id="R2aa23c229df24dcf"/>
   </p:sldIdLst>
   <p:sldSz cx="12192000" cy="6858000"/>
   <p:notesSz cx="6858000" cy="9144000"/>
@@ -454,7 +454,7 @@
           <a:lstStyle xmlns:a="http://schemas.openxmlformats.org/drawingml/2006/main"/>
           <a:p xmlns:a="http://schemas.openxmlformats.org/drawingml/2006/main">
             <a:r>
-              <a:t>00–02 min. Ouvrir sur la promesse vérifiable : un besoin simple, un ticket lisible, une exécution dans PDO, puis une revue humaine du résultat. Ne pas présenter PDSF et PDO comme deux noms pour le même produit.</a:t>
+              <a:t>00–02 min. Poser le défi sans jargon : « Notre responsable veut une note claire pour arbitrer trois idées IA. Comment passer de cette demande à un résultat que l’on peut relire ? » Annoncer le fil conducteur de cette séance de 40 minutes : issue GitHub #1, pipeline PDO, run terminé inspecté, puis PR #2 en brouillon créée après revue humaine. PDSF et PDO jouent deux rôles complémentaires.</a:t>
             </a:r>
           </a:p>
           <a:p xmlns:a="http://schemas.openxmlformats.org/drawingml/2006/main">
@@ -634,7 +634,7 @@
           <a:lstStyle xmlns:a="http://schemas.openxmlformats.org/drawingml/2006/main"/>
           <a:p xmlns:a="http://schemas.openxmlformats.org/drawingml/2006/main">
             <a:r>
-              <a:t>33–36 min. Montrer le parcours de recette seulement si la fonction est effectivement présente dans le run vérifié ou dans la branche correspondante. Modifier une valeur, copier la note, vérifier son contenu puis ouvrir l’aperçu impression/PDF. Dire d’où provient cette version : branche du run ou branche publiée. Scores fictifs, pas de connexion aux données de l’entreprise, décision finale humaine.</a:t>
+              <a:t>33–36 min. Démontrer la branche vérifiée : modifier une valeur, copier la note, contrôler le contenu, puis ouvrir l’aperçu impression/PDF. Demander ensuite un mini-vote : les preuves suffisent-elles à ouvrir une PR de revue ? Faire citer ce qu’une personne doit encore relire : diff, comportement réel, limites de l’usage métier. La version montrée provient de la branche du run ou de la branche d’intégration publiée ; annoncer laquelle est ouverte. Scores fictifs, pas de connexion aux données de l’entreprise, décision finale humaine.</a:t>
             </a:r>
           </a:p>
           <a:p xmlns:a="http://schemas.openxmlformats.org/drawingml/2006/main">
@@ -729,7 +729,7 @@
           <a:lstStyle xmlns:a="http://schemas.openxmlformats.org/drawingml/2006/main"/>
           <a:p xmlns:a="http://schemas.openxmlformats.org/drawingml/2006/main">
             <a:r>
-              <a:t>36–38 min. Rappeler la distinction essentielle. Les prompts du pipeline de démonstration interdisent au reviewer de pousser, d’ouvrir une PR ou de modifier l’issue. Le run travaille dans une branche et un worktree isolés. Après examen du diff, des tests et de l’interface, une personne décide de créer ou non une PR et de clore ou non le ticket. Dans cet atelier, une PR #2 en brouillon a été ouverte manuellement vers develop après la revue. Elle est encore non fusionnée et l’issue #1 reste ouverte.</a:t>
+              <a:t>36–38 min. Reprendre le vote : oui pour une PR de revue ne signifie pas oui pour la fusion. Les prompts du pipeline de démonstration interdisent au reviewer de pousser, d’ouvrir une PR ou de modifier l’issue. Le run travaille dans une branche et un worktree isolés. Après examen du diff, des tests et de l’interface, une personne décide de créer ou non une PR et de clore ou non le ticket. Ici, une PR #2 en brouillon a été ouverte manuellement vers develop après la revue. Elle est encore non fusionnée et l’issue #1 reste ouverte.</a:t>
             </a:r>
           </a:p>
           <a:p xmlns:a="http://schemas.openxmlformats.org/drawingml/2006/main">
@@ -829,7 +829,7 @@
           <a:lstStyle xmlns:a="http://schemas.openxmlformats.org/drawingml/2006/main"/>
           <a:p xmlns:a="http://schemas.openxmlformats.org/drawingml/2006/main">
             <a:r>
-              <a:t>38–40 min. Prendre deux questions. Proposer un second atelier technique pour installer PDSF sur un autre dépôt ou construire un pipeline PDO adapté à un vrai cas. Les liens sur la diapositive doivent pointer vers les livrables réels, pas vers un emplacement hypothétique. Ne pas afficher de secrets, données clients ou authentification pendant la séance.</a:t>
+              <a:t>38–40 min. Prendre deux questions. Rappeler l’issue #1, le run terminé inspecté et la PR #2 encore en brouillon : voilà ce que l’équipe peut vérifier après l’atelier. Proposer un second atelier technique pour installer PDSF sur un autre dépôt ou construire un pipeline PDO adapté à un vrai cas. Les liens pointent vers les livrables réels. Ne pas afficher de secrets, données clients ou authentification pendant la séance.</a:t>
             </a:r>
           </a:p>
           <a:p xmlns:a="http://schemas.openxmlformats.org/drawingml/2006/main">
@@ -850,6 +850,11 @@
           <a:p xmlns:a="http://schemas.openxmlformats.org/drawingml/2006/main">
             <a:r>
               <a:t>- https://github.com/Mohamedballouch/radar-ia-casablanca-demo/issues/1</a:t>
+            </a:r>
+          </a:p>
+          <a:p xmlns:a="http://schemas.openxmlformats.org/drawingml/2006/main">
+            <a:r>
+              <a:t>- https://github.com/Mohamedballouch/radar-ia-casablanca-demo/pull/2</a:t>
             </a:r>
           </a:p>
           <a:p xmlns:a="http://schemas.openxmlformats.org/drawingml/2006/main">
@@ -934,7 +939,7 @@
           <a:lstStyle xmlns:a="http://schemas.openxmlformats.org/drawingml/2006/main"/>
           <a:p xmlns:a="http://schemas.openxmlformats.org/drawingml/2006/main">
             <a:r>
-              <a:t>02–06 min. Ouvrir le produit avant de détailler les outils. Demander quel cas l’équipe prioriserait et pourquoi. Les trois scénarios et les scores sont fictifs ; aucun système d’entreprise ni donnée client ne se trouve dans la démonstration. Le score sert à ouvrir une discussion, pas à décider un investissement.</a:t>
+              <a:t>02–06 min. Faire voter rapidement à main levée : quel cas l’équipe prioriserait-elle, et sur quel critère ? Ouvrir ensuite le produit. Les trois scénarios et les scores sont fictifs ; aucun système d’entreprise ni donnée client ne se trouve dans la démonstration. Le score sert à ouvrir une discussion, pas à décider un investissement.</a:t>
             </a:r>
           </a:p>
           <a:p xmlns:a="http://schemas.openxmlformats.org/drawingml/2006/main">
@@ -1119,7 +1124,7 @@
           <a:lstStyle xmlns:a="http://schemas.openxmlformats.org/drawingml/2006/main"/>
           <a:p xmlns:a="http://schemas.openxmlformats.org/drawingml/2006/main">
             <a:r>
-              <a:t>08–10 min. Expliquer les deux backlogs. /to-us aide à écrire les User Stories métier ; /grill-with-docs précise le domaine dans CONTEXT.md et les ADR ; /to-spec synthétise ; /to-tickets découpe en tickets techniques. /implement utilise TDD, revue indépendante et agentic-tests quand les capacités du harness le permettent. Le parcours est guidé, sans gate absolue. La conception reste le lieu de la décision humaine.</a:t>
+              <a:t>08–10 min. Demander au public une réponse courte à chacune des deux questions. Pour la seconde : le classement et la note doivent se mettre à jour, y compris en cas d’ex æquo. Expliquer ensuite le parcours PDSF : /to-us aide à écrire les User Stories métier ; /grill-with-docs peut préciser le domaine dans CONTEXT.md et les ADR ; /to-spec synthétise ; /to-tickets découpe en tickets techniques. Ces questions empruntent l’esprit de clarification du dojo partagé, sans prétendre qu’un mode context ou un skill de grill a été exécuté pendant cette démonstration. Le PO et le développeur gardent les décisions structurantes.</a:t>
             </a:r>
           </a:p>
           <a:p xmlns:a="http://schemas.openxmlformats.org/drawingml/2006/main">
@@ -1294,7 +1299,7 @@
           <a:lstStyle xmlns:a="http://schemas.openxmlformats.org/drawingml/2006/main"/>
           <a:p xmlns:a="http://schemas.openxmlformats.org/drawingml/2006/main">
             <a:r>
-              <a:t>14–16 min. PDO fonctionne ici comme daemon dans Ubuntu. Le pipeline appartient à la bibliothèque d’instance (~/.pdo/pipelines/). Le New Run choisit explicitement un dépôt local, une branche source, un pipeline et un prompt. Agent, Script et Merge répondent à des besoins différents ; le pipeline de cet atelier emploie des Agents. PDO peut fonctionner sans PDSF, et PDSF peut guider un agent sans PDO.</a:t>
+              <a:t>14–16 min. Demander au public de prédire le rôle du nœud de revue et la branche d’échec avant de révéler le vrai canvas de la diapositive suivante. PDO fonctionne ici comme daemon dans Ubuntu. Le pipeline appartient à la bibliothèque d’instance (~/.pdo/pipelines/). New Run choisit explicitement un dépôt local, une branche source, un pipeline et un prompt. Agent, Script et Merge répondent à des besoins différents ; le pipeline de cet atelier emploie des Agents. PDO peut fonctionner sans PDSF, et PDSF peut guider un agent sans PDO.</a:t>
             </a:r>
           </a:p>
           <a:p xmlns:a="http://schemas.openxmlformats.org/drawingml/2006/main">
@@ -1384,7 +1389,7 @@
           <a:lstStyle xmlns:a="http://schemas.openxmlformats.org/drawingml/2006/main"/>
           <a:p xmlns:a="http://schemas.openxmlformats.org/drawingml/2006/main">
             <a:r>
-              <a:t>16–19 min. Ouvrir dans PDO le pipeline atelier-radar-ia, puis expliquer les rôles et les sorties attendues. Le YAML préparé contient Start, Lire le ticket, Développer la fonction, Vérifier la fonction, Brief manager, End. Le nœud Vérifier produit un verdict pass/fail en frontmatter ; fail revient à Développer. La boucle est bornée à trois itérations. Le nœud de revue doit examiner code, diff, tests et build ; ce sont des instructions du pipeline, pas encore une preuve que l’exécution a eu lieu.</a:t>
+              <a:t>16–19 min. Après les réponses du public, ouvrir le vrai canvas PDO de atelier-radar-ia. Le YAML contient Start, Lire le ticket, Développer la fonction, Vérifier la fonction, Brief manager, End. Demander de repérer la branche fail : elle revient à Développer, avec trois itérations maximum. Le nœud Vérifier produit un verdict pass/fail en frontmatter. La configuration du pipeline prescrit l’examen du code, du diff, des tests et du build ; les preuves d’exécution seront visibles dans le run.</a:t>
             </a:r>
           </a:p>
           <a:p xmlns:a="http://schemas.openxmlformats.org/drawingml/2006/main">
@@ -1652,7 +1657,7 @@
   </p:cSld>
   <p:clrMap bg1="lt1" tx1="dk1" bg2="lt2" tx2="dk2" accent1="accent1" accent2="accent2" accent3="accent3" accent4="accent4" accent5="accent5" accent6="accent6" hlink="hlink" folHlink="folHlink"/>
   <p:sldLayoutIdLst>
-    <p:sldLayoutId xmlns:r="http://schemas.openxmlformats.org/officeDocument/2006/relationships" id="2147483649" r:id="R2dd68b8e3741412b"/>
+    <p:sldLayoutId xmlns:r="http://schemas.openxmlformats.org/officeDocument/2006/relationships" id="2147483649" r:id="R29c79b625537458f"/>
   </p:sldLayoutIdLst>
   <p:txStyles>
     <p:titleStyle>
@@ -2203,7 +2208,7 @@
           <p:cNvPr id="5" name="cover-title">
             <a:extLst xmlns:a="http://schemas.openxmlformats.org/drawingml/2006/main">
               <a:ext uri="{FF2B5EF4-FFF2-40B4-BE49-F238E27FC236}">
-                <a16:creationId xmlns:a16="http://schemas.microsoft.com/office/drawing/2014/main" id="{0C35F517-67C1-46F3-A816-E0E86D9122AA}"/>
+                <a16:creationId xmlns:a16="http://schemas.microsoft.com/office/drawing/2014/main" id="{1719022B-23AD-4E66-8CF8-2FC9B41D2100}"/>
               </a:ext>
             </a:extLst>
           </p:cNvPr>
@@ -2260,7 +2265,7 @@
           <p:cNvPr id="2" name="cover-subtitle">
             <a:extLst xmlns:a="http://schemas.openxmlformats.org/drawingml/2006/main">
               <a:ext uri="{FF2B5EF4-FFF2-40B4-BE49-F238E27FC236}">
-                <a16:creationId xmlns:a16="http://schemas.microsoft.com/office/drawing/2014/main" id="{5607A262-F75C-4B8F-9ED4-CA35503030F8}"/>
+                <a16:creationId xmlns:a16="http://schemas.microsoft.com/office/drawing/2014/main" id="{BB0E33F3-8F7A-4054-9618-1671692E08CC}"/>
               </a:ext>
             </a:extLst>
           </p:cNvPr>
@@ -2272,7 +2277,7 @@
         <p:spPr>
           <a:xfrm xmlns:a="http://schemas.openxmlformats.org/drawingml/2006/main">
             <a:off x="714375" y="2514600"/>
-            <a:ext cx="10382250" cy="781050"/>
+            <a:ext cx="10477500" cy="781050"/>
           </a:xfrm>
           <a:prstGeom xmlns:a="http://schemas.openxmlformats.org/drawingml/2006/main" prst="rect">
             <a:avLst/>
@@ -2289,25 +2294,25 @@
           <a:lstStyle xmlns:a="http://schemas.openxmlformats.org/drawingml/2006/main"/>
           <a:p xmlns:a="http://schemas.openxmlformats.org/drawingml/2006/main">
             <a:pPr algn="l">
-              <a:defRPr sz="2625" b="0">
-                <a:solidFill>
-                  <a:srgbClr val="FFFFFF"/>
-                </a:solidFill>
-                <a:latin typeface="Arial"/>
-                <a:ea typeface="Arial"/>
-                <a:cs typeface="Arial"/>
-              </a:defRPr>
-            </a:pPr>
-            <a:r>
-              <a:rPr sz="2625" b="0">
-                <a:solidFill>
-                  <a:srgbClr val="FFFFFF"/>
-                </a:solidFill>
-                <a:latin typeface="Arial"/>
-                <a:ea typeface="Arial"/>
-                <a:cs typeface="Arial"/>
-              </a:rPr>
-              <a:t>Du besoin métier au résultat vérifiable</a:t>
+              <a:defRPr sz="2550" b="0">
+                <a:solidFill>
+                  <a:srgbClr val="E9A93C"/>
+                </a:solidFill>
+                <a:latin typeface="Arial"/>
+                <a:ea typeface="Arial"/>
+                <a:cs typeface="Arial"/>
+              </a:defRPr>
+            </a:pPr>
+            <a:r>
+              <a:rPr sz="2550" b="0">
+                <a:solidFill>
+                  <a:srgbClr val="E9A93C"/>
+                </a:solidFill>
+                <a:latin typeface="Arial"/>
+                <a:ea typeface="Arial"/>
+                <a:cs typeface="Arial"/>
+              </a:rPr>
+              <a:t>Une issue réelle, un run inspecté, une PR à relire</a:t>
             </a:r>
           </a:p>
         </p:txBody>
@@ -2317,7 +2322,7 @@
           <p:cNvPr id="3" name="cover-expanded">
             <a:extLst xmlns:a="http://schemas.openxmlformats.org/drawingml/2006/main">
               <a:ext uri="{FF2B5EF4-FFF2-40B4-BE49-F238E27FC236}">
-                <a16:creationId xmlns:a16="http://schemas.microsoft.com/office/drawing/2014/main" id="{C4AEA00C-D4CE-47A5-BF2D-04ED4F74B697}"/>
+                <a16:creationId xmlns:a16="http://schemas.microsoft.com/office/drawing/2014/main" id="{4A07887F-DF1D-4CEF-A18D-DEF53FD2F987}"/>
               </a:ext>
             </a:extLst>
           </p:cNvPr>
@@ -2374,7 +2379,7 @@
           <p:cNvPr id="4" name="cover-meta">
             <a:extLst xmlns:a="http://schemas.openxmlformats.org/drawingml/2006/main">
               <a:ext uri="{FF2B5EF4-FFF2-40B4-BE49-F238E27FC236}">
-                <a16:creationId xmlns:a16="http://schemas.microsoft.com/office/drawing/2014/main" id="{DFEB4726-346C-48AE-95AC-9608D904439D}"/>
+                <a16:creationId xmlns:a16="http://schemas.microsoft.com/office/drawing/2014/main" id="{7A79085E-1086-4853-8375-B9F549B3C5A8}"/>
               </a:ext>
             </a:extLst>
           </p:cNvPr>
@@ -2429,7 +2434,7 @@
     </p:spTree>
     <p:extLst>
       <p:ext uri="{BB962C8B-B14F-4D97-AF65-F5344CB8AC3E}">
-        <p14:creationId xmlns:p14="http://schemas.microsoft.com/office/powerpoint/2010/main" val="2007031219"/>
+        <p14:creationId xmlns:p14="http://schemas.microsoft.com/office/powerpoint/2010/main" val="901557552"/>
       </p:ext>
     </p:extLst>
   </p:cSld>
@@ -2460,7 +2465,7 @@
           <p:cNvPr id="6" name="title-10">
             <a:extLst xmlns:a="http://schemas.openxmlformats.org/drawingml/2006/main">
               <a:ext uri="{FF2B5EF4-FFF2-40B4-BE49-F238E27FC236}">
-                <a16:creationId xmlns:a16="http://schemas.microsoft.com/office/drawing/2014/main" id="{818A73DA-3B70-471B-95C5-72BDA22BB6D0}"/>
+                <a16:creationId xmlns:a16="http://schemas.microsoft.com/office/drawing/2014/main" id="{0E815C58-A02D-44A3-A3D5-F56B434B256B}"/>
               </a:ext>
             </a:extLst>
           </p:cNvPr>
@@ -2507,7 +2512,7 @@
                 <a:ea typeface="Arial"/>
                 <a:cs typeface="Arial"/>
               </a:rPr>
-              <a:t>Inspection : une preuve par nœud</a:t>
+              <a:t>Que prouve chaque nœud ?</a:t>
             </a:r>
           </a:p>
         </p:txBody>
@@ -2517,7 +2522,7 @@
           <p:cNvPr id="2" name="page-10">
             <a:extLst xmlns:a="http://schemas.openxmlformats.org/drawingml/2006/main">
               <a:ext uri="{FF2B5EF4-FFF2-40B4-BE49-F238E27FC236}">
-                <a16:creationId xmlns:a16="http://schemas.microsoft.com/office/drawing/2014/main" id="{E8E18928-B8DD-4BD3-8994-942908F90AF1}"/>
+                <a16:creationId xmlns:a16="http://schemas.microsoft.com/office/drawing/2014/main" id="{B364683E-BFCD-4893-9587-ADF51F32FCF5}"/>
               </a:ext>
             </a:extLst>
           </p:cNvPr>
@@ -2574,7 +2579,7 @@
           <p:cNvPr id="3" name="inspect-nodes">
             <a:extLst xmlns:a="http://schemas.openxmlformats.org/drawingml/2006/main">
               <a:ext uri="{FF2B5EF4-FFF2-40B4-BE49-F238E27FC236}">
-                <a16:creationId xmlns:a16="http://schemas.microsoft.com/office/drawing/2014/main" id="{C87D3B18-81C4-4BF6-BC58-3993AEBA5DCE}"/>
+                <a16:creationId xmlns:a16="http://schemas.microsoft.com/office/drawing/2014/main" id="{E89C90FF-862B-488C-91E0-891A80B9E624}"/>
               </a:ext>
             </a:extLst>
           </p:cNvPr>
@@ -2644,7 +2649,7 @@
                 <a:ea typeface="Arial"/>
                 <a:cs typeface="Arial"/>
               </a:rPr>
-              <a:t>Brief issu de l’issue #1</a:t>
+              <a:t>Critères extraits de l’issue #1</a:t>
             </a:r>
           </a:p>
           <a:p xmlns:a="http://schemas.openxmlformats.org/drawingml/2006/main">
@@ -2695,7 +2700,7 @@
                 <a:ea typeface="Arial"/>
                 <a:cs typeface="Arial"/>
               </a:rPr>
-              <a:t>Changements dans le worktree du run</a:t>
+              <a:t>Diff et tests proposés</a:t>
             </a:r>
           </a:p>
           <a:p xmlns:a="http://schemas.openxmlformats.org/drawingml/2006/main">
@@ -2811,7 +2816,7 @@
           <p:nvPr/>
         </p:nvPicPr>
         <p:blipFill>
-          <a:blip xmlns:r="http://schemas.openxmlformats.org/officeDocument/2006/relationships" xmlns:a="http://schemas.openxmlformats.org/drawingml/2006/main" r:embed="R04447238f155497c"/>
+          <a:blip xmlns:r="http://schemas.openxmlformats.org/officeDocument/2006/relationships" xmlns:a="http://schemas.openxmlformats.org/drawingml/2006/main" r:embed="R04821ee79e814142"/>
           <a:stretch xmlns:a="http://schemas.openxmlformats.org/drawingml/2006/main"/>
         </p:blipFill>
         <p:spPr>
@@ -2829,7 +2834,7 @@
           <p:cNvPr id="5" name="inspect-surfaces">
             <a:extLst xmlns:a="http://schemas.openxmlformats.org/drawingml/2006/main">
               <a:ext uri="{FF2B5EF4-FFF2-40B4-BE49-F238E27FC236}">
-                <a16:creationId xmlns:a16="http://schemas.microsoft.com/office/drawing/2014/main" id="{00B58A7B-39CD-4DAD-A95E-75FFAA925118}"/>
+                <a16:creationId xmlns:a16="http://schemas.microsoft.com/office/drawing/2014/main" id="{E090AC1F-5FC9-4925-9025-6C8407C862A0}"/>
               </a:ext>
             </a:extLst>
           </p:cNvPr>
@@ -2876,7 +2881,7 @@
                 <a:ea typeface="Arial"/>
                 <a:cs typeface="Arial"/>
               </a:rPr>
-              <a:t>Contrôles : Outputs, Terminal, Repositories, Diff et YAML</a:t>
+              <a:t>Dans PDO : Inputs, Outputs, Terminal, Repositories, Diff et YAML</a:t>
             </a:r>
           </a:p>
         </p:txBody>
@@ -2884,7 +2889,7 @@
     </p:spTree>
     <p:extLst>
       <p:ext uri="{BB962C8B-B14F-4D97-AF65-F5344CB8AC3E}">
-        <p14:creationId xmlns:p14="http://schemas.microsoft.com/office/powerpoint/2010/main" val="1918578286"/>
+        <p14:creationId xmlns:p14="http://schemas.microsoft.com/office/powerpoint/2010/main" val="1958071080"/>
       </p:ext>
     </p:extLst>
   </p:cSld>
@@ -2915,7 +2920,7 @@
           <p:cNvPr id="5" name="title-11">
             <a:extLst xmlns:a="http://schemas.openxmlformats.org/drawingml/2006/main">
               <a:ext uri="{FF2B5EF4-FFF2-40B4-BE49-F238E27FC236}">
-                <a16:creationId xmlns:a16="http://schemas.microsoft.com/office/drawing/2014/main" id="{763EA0DD-D09B-457B-9CF3-2863B0DC5B4A}"/>
+                <a16:creationId xmlns:a16="http://schemas.microsoft.com/office/drawing/2014/main" id="{C3BAC841-0421-473A-9394-7DD4860CDD1D}"/>
               </a:ext>
             </a:extLst>
           </p:cNvPr>
@@ -2944,7 +2949,7 @@
           <a:lstStyle xmlns:a="http://schemas.openxmlformats.org/drawingml/2006/main"/>
           <a:p xmlns:a="http://schemas.openxmlformats.org/drawingml/2006/main">
             <a:pPr algn="l">
-              <a:defRPr sz="3000" b="1">
+              <a:defRPr sz="2850" b="1">
                 <a:solidFill>
                   <a:srgbClr val="14202B"/>
                 </a:solidFill>
@@ -2954,7 +2959,7 @@
               </a:defRPr>
             </a:pPr>
             <a:r>
-              <a:rPr sz="3000" b="1">
+              <a:rPr sz="2850" b="1">
                 <a:solidFill>
                   <a:srgbClr val="14202B"/>
                 </a:solidFill>
@@ -2962,7 +2967,7 @@
                 <a:ea typeface="Arial"/>
                 <a:cs typeface="Arial"/>
               </a:rPr>
-              <a:t>Résultat métier : une note partageable</a:t>
+              <a:t>Résultat métier : la note est-elle prête pour une PR ?</a:t>
             </a:r>
           </a:p>
         </p:txBody>
@@ -2972,7 +2977,7 @@
           <p:cNvPr id="2" name="page-11">
             <a:extLst xmlns:a="http://schemas.openxmlformats.org/drawingml/2006/main">
               <a:ext uri="{FF2B5EF4-FFF2-40B4-BE49-F238E27FC236}">
-                <a16:creationId xmlns:a16="http://schemas.microsoft.com/office/drawing/2014/main" id="{298AB28F-395E-430D-9B3F-6F181BB1D467}"/>
+                <a16:creationId xmlns:a16="http://schemas.microsoft.com/office/drawing/2014/main" id="{E9297FDE-E13B-439F-BC6D-5B028C384025}"/>
               </a:ext>
             </a:extLst>
           </p:cNvPr>
@@ -3033,7 +3038,7 @@
           <p:nvPr/>
         </p:nvPicPr>
         <p:blipFill>
-          <a:blip xmlns:r="http://schemas.openxmlformats.org/officeDocument/2006/relationships" xmlns:a="http://schemas.openxmlformats.org/drawingml/2006/main" r:embed="R92c0f26e213940d6"/>
+          <a:blip xmlns:r="http://schemas.openxmlformats.org/officeDocument/2006/relationships" xmlns:a="http://schemas.openxmlformats.org/drawingml/2006/main" r:embed="Rb36c6895b21441fd"/>
           <a:stretch xmlns:a="http://schemas.openxmlformats.org/drawingml/2006/main"/>
         </p:blipFill>
         <p:spPr>
@@ -3048,10 +3053,10 @@
       </p:pic>
       <p:sp>
         <p:nvSpPr>
-          <p:cNvPr id="4" name="after-steps">
+          <p:cNvPr id="4" name="after-vote">
             <a:extLst xmlns:a="http://schemas.openxmlformats.org/drawingml/2006/main">
               <a:ext uri="{FF2B5EF4-FFF2-40B4-BE49-F238E27FC236}">
-                <a16:creationId xmlns:a16="http://schemas.microsoft.com/office/drawing/2014/main" id="{1F97FD53-0229-4819-8FD6-4B833A5D64DD}"/>
+                <a16:creationId xmlns:a16="http://schemas.microsoft.com/office/drawing/2014/main" id="{ABF18065-AE0C-43C3-9812-C62DEDCCBC19}"/>
               </a:ext>
             </a:extLst>
           </p:cNvPr>
@@ -3098,7 +3103,7 @@
                 <a:ea typeface="Arial"/>
                 <a:cs typeface="Arial"/>
               </a:rPr>
-              <a:t>Modifier un critère · copier la note · ouvrir l’aperçu PDF</a:t>
+              <a:t>Mini-vote : ouvririez-vous une PR de revue avec ces preuves ?</a:t>
             </a:r>
           </a:p>
         </p:txBody>
@@ -3106,7 +3111,7 @@
     </p:spTree>
     <p:extLst>
       <p:ext uri="{BB962C8B-B14F-4D97-AF65-F5344CB8AC3E}">
-        <p14:creationId xmlns:p14="http://schemas.microsoft.com/office/powerpoint/2010/main" val="1419718285"/>
+        <p14:creationId xmlns:p14="http://schemas.microsoft.com/office/powerpoint/2010/main" val="717031038"/>
       </p:ext>
     </p:extLst>
   </p:cSld>
@@ -3137,7 +3142,7 @@
           <p:cNvPr id="5" name="title-12">
             <a:extLst xmlns:a="http://schemas.openxmlformats.org/drawingml/2006/main">
               <a:ext uri="{FF2B5EF4-FFF2-40B4-BE49-F238E27FC236}">
-                <a16:creationId xmlns:a16="http://schemas.microsoft.com/office/drawing/2014/main" id="{A01130B5-E980-4A67-A9F8-EDEEBD7E9117}"/>
+                <a16:creationId xmlns:a16="http://schemas.microsoft.com/office/drawing/2014/main" id="{04CA8852-E0D0-472B-9C81-17280A7E7B2F}"/>
               </a:ext>
             </a:extLst>
           </p:cNvPr>
@@ -3184,7 +3189,7 @@
                 <a:ea typeface="Arial"/>
                 <a:cs typeface="Arial"/>
               </a:rPr>
-              <a:t>La publication reste une décision humaine</a:t>
+              <a:t>PR #2 : une revue humaine reste nécessaire</a:t>
             </a:r>
           </a:p>
         </p:txBody>
@@ -3194,7 +3199,7 @@
           <p:cNvPr id="2" name="page-12">
             <a:extLst xmlns:a="http://schemas.openxmlformats.org/drawingml/2006/main">
               <a:ext uri="{FF2B5EF4-FFF2-40B4-BE49-F238E27FC236}">
-                <a16:creationId xmlns:a16="http://schemas.microsoft.com/office/drawing/2014/main" id="{36AB6583-5685-43F1-A721-D7EE1D6CAFC3}"/>
+                <a16:creationId xmlns:a16="http://schemas.microsoft.com/office/drawing/2014/main" id="{923EE18C-D0C1-4E8B-9A80-B16CD42152E8}"/>
               </a:ext>
             </a:extLst>
           </p:cNvPr>
@@ -3255,7 +3260,7 @@
           <p:nvPr/>
         </p:nvPicPr>
         <p:blipFill>
-          <a:blip xmlns:r="http://schemas.openxmlformats.org/officeDocument/2006/relationships" xmlns:a="http://schemas.openxmlformats.org/drawingml/2006/main" r:embed="R37519ea2128447fe"/>
+          <a:blip xmlns:r="http://schemas.openxmlformats.org/officeDocument/2006/relationships" xmlns:a="http://schemas.openxmlformats.org/drawingml/2006/main" r:embed="R5387c7b7dd5f489b"/>
           <a:stretch xmlns:a="http://schemas.openxmlformats.org/drawingml/2006/main"/>
         </p:blipFill>
         <p:spPr>
@@ -3273,7 +3278,7 @@
           <p:cNvPr id="4" name="responsibility-note">
             <a:extLst xmlns:a="http://schemas.openxmlformats.org/drawingml/2006/main">
               <a:ext uri="{FF2B5EF4-FFF2-40B4-BE49-F238E27FC236}">
-                <a16:creationId xmlns:a16="http://schemas.microsoft.com/office/drawing/2014/main" id="{0789A5F1-7B8B-469B-9B82-BBE8C8D5A804}"/>
+                <a16:creationId xmlns:a16="http://schemas.microsoft.com/office/drawing/2014/main" id="{619BEED1-D1A6-46B7-83DD-AC837100573D}"/>
               </a:ext>
             </a:extLst>
           </p:cNvPr>
@@ -3319,9 +3324,9 @@
                 <a:latin typeface="Arial"/>
                 <a:ea typeface="Arial"/>
                 <a:cs typeface="Arial"/>
-                <a:hlinkClick xmlns:r="http://schemas.openxmlformats.org/officeDocument/2006/relationships" r:id="Ree6a88e9a8414ff4"/>
-              </a:rPr>
-              <a:t>Capture du 1er octobre : PR #2 en brouillon vers develop</a:t>
+                <a:hlinkClick xmlns:r="http://schemas.openxmlformats.org/officeDocument/2006/relationships" r:id="R7b4d32bdd7ca45dd"/>
+              </a:rPr>
+              <a:t>PR #2 ouverte manuellement le 1er octobre, en brouillon vers develop</a:t>
             </a:r>
           </a:p>
         </p:txBody>
@@ -3329,7 +3334,7 @@
     </p:spTree>
     <p:extLst>
       <p:ext uri="{BB962C8B-B14F-4D97-AF65-F5344CB8AC3E}">
-        <p14:creationId xmlns:p14="http://schemas.microsoft.com/office/powerpoint/2010/main" val="1520395000"/>
+        <p14:creationId xmlns:p14="http://schemas.microsoft.com/office/powerpoint/2010/main" val="1778143599"/>
       </p:ext>
     </p:extLst>
   </p:cSld>
@@ -3357,10 +3362,10 @@
       </p:grpSpPr>
       <p:sp>
         <p:nvSpPr>
-          <p:cNvPr id="9" name="title-13">
+          <p:cNvPr id="10" name="title-13">
             <a:extLst xmlns:a="http://schemas.openxmlformats.org/drawingml/2006/main">
               <a:ext uri="{FF2B5EF4-FFF2-40B4-BE49-F238E27FC236}">
-                <a16:creationId xmlns:a16="http://schemas.microsoft.com/office/drawing/2014/main" id="{D60B45C1-6EFF-4EA0-A036-9A2A8DEC8A91}"/>
+                <a16:creationId xmlns:a16="http://schemas.microsoft.com/office/drawing/2014/main" id="{2F76B9AA-7CD8-4AF4-9BA3-F5E753848C3C}"/>
               </a:ext>
             </a:extLst>
           </p:cNvPr>
@@ -3407,7 +3412,7 @@
                 <a:ea typeface="Arial"/>
                 <a:cs typeface="Arial"/>
               </a:rPr>
-              <a:t>Questions et prochain essai</a:t>
+              <a:t>Une issue, un run, une PR à relire</a:t>
             </a:r>
           </a:p>
         </p:txBody>
@@ -3417,7 +3422,7 @@
           <p:cNvPr id="2" name="page-13">
             <a:extLst xmlns:a="http://schemas.openxmlformats.org/drawingml/2006/main">
               <a:ext uri="{FF2B5EF4-FFF2-40B4-BE49-F238E27FC236}">
-                <a16:creationId xmlns:a16="http://schemas.microsoft.com/office/drawing/2014/main" id="{C76F4CC0-68E8-46FC-89C7-5B8DBA65ACB6}"/>
+                <a16:creationId xmlns:a16="http://schemas.microsoft.com/office/drawing/2014/main" id="{7CB712DE-5158-4810-A9CA-8D7701EC61F4}"/>
               </a:ext>
             </a:extLst>
           </p:cNvPr>
@@ -3474,7 +3479,7 @@
           <p:cNvPr id="3" name="next-prompt">
             <a:extLst xmlns:a="http://schemas.openxmlformats.org/drawingml/2006/main">
               <a:ext uri="{FF2B5EF4-FFF2-40B4-BE49-F238E27FC236}">
-                <a16:creationId xmlns:a16="http://schemas.microsoft.com/office/drawing/2014/main" id="{25ECDB11-FFEF-41F5-B57E-B62ADE0934CE}"/>
+                <a16:creationId xmlns:a16="http://schemas.microsoft.com/office/drawing/2014/main" id="{95A0182E-0F14-4EA3-B446-CF1F997015E6}"/>
               </a:ext>
             </a:extLst>
           </p:cNvPr>
@@ -3521,7 +3526,7 @@
                 <a:ea typeface="Arial"/>
                 <a:cs typeface="Arial"/>
               </a:rPr>
-              <a:t>Choisir une petite demande, avec des critères observables et sans donnée sensible.</a:t>
+              <a:t>Pour le prochain essai : une petite demande avec des critères observables.</a:t>
             </a:r>
           </a:p>
         </p:txBody>
@@ -3531,7 +3536,7 @@
           <p:cNvPr id="4" name="link-repo">
             <a:extLst xmlns:a="http://schemas.openxmlformats.org/drawingml/2006/main">
               <a:ext uri="{FF2B5EF4-FFF2-40B4-BE49-F238E27FC236}">
-                <a16:creationId xmlns:a16="http://schemas.microsoft.com/office/drawing/2014/main" id="{2B199EF1-4A99-47B4-B235-4BAD7B95AD5A}"/>
+                <a16:creationId xmlns:a16="http://schemas.microsoft.com/office/drawing/2014/main" id="{4AC14D62-1D26-4BCB-990C-2FFD3BA91311}"/>
               </a:ext>
             </a:extLst>
           </p:cNvPr>
@@ -3542,7 +3547,7 @@
         </p:nvSpPr>
         <p:spPr>
           <a:xfrm xmlns:a="http://schemas.openxmlformats.org/drawingml/2006/main">
-            <a:off x="666750" y="3486150"/>
+            <a:off x="666750" y="3228975"/>
             <a:ext cx="10477500" cy="428625"/>
           </a:xfrm>
           <a:prstGeom xmlns:a="http://schemas.openxmlformats.org/drawingml/2006/main" prst="rect">
@@ -3562,7 +3567,7 @@
             <a:pPr algn="l">
               <a:defRPr sz="1800" b="0">
                 <a:solidFill>
-                  <a:srgbClr val="8BE0C9"/>
+                  <a:srgbClr val="E9A93C"/>
                 </a:solidFill>
                 <a:latin typeface="Arial"/>
                 <a:ea typeface="Arial"/>
@@ -3572,12 +3577,12 @@
             <a:r>
               <a:rPr sz="1800" b="0">
                 <a:solidFill>
-                  <a:srgbClr val="8BE0C9"/>
-                </a:solidFill>
-                <a:latin typeface="Arial"/>
-                <a:ea typeface="Arial"/>
-                <a:cs typeface="Arial"/>
-                <a:hlinkClick xmlns:r="http://schemas.openxmlformats.org/officeDocument/2006/relationships" r:id="R0c16551c478f4953"/>
+                  <a:srgbClr val="E9A93C"/>
+                </a:solidFill>
+                <a:latin typeface="Arial"/>
+                <a:ea typeface="Arial"/>
+                <a:cs typeface="Arial"/>
+                <a:hlinkClick xmlns:r="http://schemas.openxmlformats.org/officeDocument/2006/relationships" r:id="R601de6b8e6834aa1"/>
               </a:rPr>
               <a:t>Dépôt : Radar IA Casablanca</a:t>
             </a:r>
@@ -3589,7 +3594,7 @@
           <p:cNvPr id="5" name="link-issue">
             <a:extLst xmlns:a="http://schemas.openxmlformats.org/drawingml/2006/main">
               <a:ext uri="{FF2B5EF4-FFF2-40B4-BE49-F238E27FC236}">
-                <a16:creationId xmlns:a16="http://schemas.microsoft.com/office/drawing/2014/main" id="{D427C065-274B-49A5-9434-1029288334E5}"/>
+                <a16:creationId xmlns:a16="http://schemas.microsoft.com/office/drawing/2014/main" id="{658C1895-0A77-49D4-8334-1D291A498F58}"/>
               </a:ext>
             </a:extLst>
           </p:cNvPr>
@@ -3600,7 +3605,7 @@
         </p:nvSpPr>
         <p:spPr>
           <a:xfrm xmlns:a="http://schemas.openxmlformats.org/drawingml/2006/main">
-            <a:off x="666750" y="4029075"/>
+            <a:off x="666750" y="3705225"/>
             <a:ext cx="10477500" cy="428625"/>
           </a:xfrm>
           <a:prstGeom xmlns:a="http://schemas.openxmlformats.org/drawingml/2006/main" prst="rect">
@@ -3620,7 +3625,7 @@
             <a:pPr algn="l">
               <a:defRPr sz="1800" b="0">
                 <a:solidFill>
-                  <a:srgbClr val="8BE0C9"/>
+                  <a:srgbClr val="E9A93C"/>
                 </a:solidFill>
                 <a:latin typeface="Arial"/>
                 <a:ea typeface="Arial"/>
@@ -3630,12 +3635,12 @@
             <a:r>
               <a:rPr sz="1800" b="0">
                 <a:solidFill>
-                  <a:srgbClr val="8BE0C9"/>
-                </a:solidFill>
-                <a:latin typeface="Arial"/>
-                <a:ea typeface="Arial"/>
-                <a:cs typeface="Arial"/>
-                <a:hlinkClick xmlns:r="http://schemas.openxmlformats.org/officeDocument/2006/relationships" r:id="R086ffccdcc504e11"/>
+                  <a:srgbClr val="E9A93C"/>
+                </a:solidFill>
+                <a:latin typeface="Arial"/>
+                <a:ea typeface="Arial"/>
+                <a:cs typeface="Arial"/>
+                <a:hlinkClick xmlns:r="http://schemas.openxmlformats.org/officeDocument/2006/relationships" r:id="R8aa69c988f85427b"/>
               </a:rPr>
               <a:t>Issue #1</a:t>
             </a:r>
@@ -3644,10 +3649,10 @@
       </p:sp>
       <p:sp>
         <p:nvSpPr>
-          <p:cNvPr id="6" name="link-video-product">
+          <p:cNvPr id="6" name="link-pr">
             <a:extLst xmlns:a="http://schemas.openxmlformats.org/drawingml/2006/main">
               <a:ext uri="{FF2B5EF4-FFF2-40B4-BE49-F238E27FC236}">
-                <a16:creationId xmlns:a16="http://schemas.microsoft.com/office/drawing/2014/main" id="{D4AC0209-57E2-45F4-8C90-4FBF570489C7}"/>
+                <a16:creationId xmlns:a16="http://schemas.microsoft.com/office/drawing/2014/main" id="{F58B6C99-3810-4C31-8507-D48BD70A20BD}"/>
               </a:ext>
             </a:extLst>
           </p:cNvPr>
@@ -3658,7 +3663,7 @@
         </p:nvSpPr>
         <p:spPr>
           <a:xfrm xmlns:a="http://schemas.openxmlformats.org/drawingml/2006/main">
-            <a:off x="666750" y="4572000"/>
+            <a:off x="666750" y="4181475"/>
             <a:ext cx="10477500" cy="428625"/>
           </a:xfrm>
           <a:prstGeom xmlns:a="http://schemas.openxmlformats.org/drawingml/2006/main" prst="rect">
@@ -3678,7 +3683,7 @@
             <a:pPr algn="l">
               <a:defRPr sz="1800" b="0">
                 <a:solidFill>
-                  <a:srgbClr val="8BE0C9"/>
+                  <a:srgbClr val="E9A93C"/>
                 </a:solidFill>
                 <a:latin typeface="Arial"/>
                 <a:ea typeface="Arial"/>
@@ -3688,24 +3693,24 @@
             <a:r>
               <a:rPr sz="1800" b="0">
                 <a:solidFill>
-                  <a:srgbClr val="8BE0C9"/>
-                </a:solidFill>
-                <a:latin typeface="Arial"/>
-                <a:ea typeface="Arial"/>
-                <a:cs typeface="Arial"/>
-                <a:hlinkClick xmlns:r="http://schemas.openxmlformats.org/officeDocument/2006/relationships" r:id="Re20cddd5f4164e5d"/>
-              </a:rPr>
-              <a:t>MP4 : produit et issue GitHub</a:t>
-            </a:r>
-          </a:p>
-        </p:txBody>
-      </p:sp>
-      <p:sp>
-        <p:nvSpPr>
-          <p:cNvPr id="7" name="link-video-pdo">
+                  <a:srgbClr val="E9A93C"/>
+                </a:solidFill>
+                <a:latin typeface="Arial"/>
+                <a:ea typeface="Arial"/>
+                <a:cs typeface="Arial"/>
+                <a:hlinkClick xmlns:r="http://schemas.openxmlformats.org/officeDocument/2006/relationships" r:id="Rda803b1783234751"/>
+              </a:rPr>
+              <a:t>PR #2 : revue en brouillon</a:t>
+            </a:r>
+          </a:p>
+        </p:txBody>
+      </p:sp>
+      <p:sp>
+        <p:nvSpPr>
+          <p:cNvPr id="7" name="link-video-product">
             <a:extLst xmlns:a="http://schemas.openxmlformats.org/drawingml/2006/main">
               <a:ext uri="{FF2B5EF4-FFF2-40B4-BE49-F238E27FC236}">
-                <a16:creationId xmlns:a16="http://schemas.microsoft.com/office/drawing/2014/main" id="{D7FD31BE-3558-4FF4-9611-C0DEC1DC7DFA}"/>
+                <a16:creationId xmlns:a16="http://schemas.microsoft.com/office/drawing/2014/main" id="{F17F935A-0C67-4249-AABF-C17FE5C47A88}"/>
               </a:ext>
             </a:extLst>
           </p:cNvPr>
@@ -3716,7 +3721,7 @@
         </p:nvSpPr>
         <p:spPr>
           <a:xfrm xmlns:a="http://schemas.openxmlformats.org/drawingml/2006/main">
-            <a:off x="666750" y="5114925"/>
+            <a:off x="666750" y="4657725"/>
             <a:ext cx="10477500" cy="428625"/>
           </a:xfrm>
           <a:prstGeom xmlns:a="http://schemas.openxmlformats.org/drawingml/2006/main" prst="rect">
@@ -3736,7 +3741,7 @@
             <a:pPr algn="l">
               <a:defRPr sz="1800" b="0">
                 <a:solidFill>
-                  <a:srgbClr val="8BE0C9"/>
+                  <a:srgbClr val="E9A93C"/>
                 </a:solidFill>
                 <a:latin typeface="Arial"/>
                 <a:ea typeface="Arial"/>
@@ -3746,24 +3751,24 @@
             <a:r>
               <a:rPr sz="1800" b="0">
                 <a:solidFill>
-                  <a:srgbClr val="8BE0C9"/>
-                </a:solidFill>
-                <a:latin typeface="Arial"/>
-                <a:ea typeface="Arial"/>
-                <a:cs typeface="Arial"/>
-                <a:hlinkClick xmlns:r="http://schemas.openxmlformats.org/officeDocument/2006/relationships" r:id="R945e34899b0a4f80"/>
-              </a:rPr>
-              <a:t>MP4 : pipeline et inspection PDO</a:t>
-            </a:r>
-          </a:p>
-        </p:txBody>
-      </p:sp>
-      <p:sp>
-        <p:nvSpPr>
-          <p:cNvPr id="8" name="link-pdf">
+                  <a:srgbClr val="E9A93C"/>
+                </a:solidFill>
+                <a:latin typeface="Arial"/>
+                <a:ea typeface="Arial"/>
+                <a:cs typeface="Arial"/>
+                <a:hlinkClick xmlns:r="http://schemas.openxmlformats.org/officeDocument/2006/relationships" r:id="R7fdd66fdd78843c3"/>
+              </a:rPr>
+              <a:t>MP4 : produit et issue GitHub</a:t>
+            </a:r>
+          </a:p>
+        </p:txBody>
+      </p:sp>
+      <p:sp>
+        <p:nvSpPr>
+          <p:cNvPr id="8" name="link-video-pdo">
             <a:extLst xmlns:a="http://schemas.openxmlformats.org/drawingml/2006/main">
               <a:ext uri="{FF2B5EF4-FFF2-40B4-BE49-F238E27FC236}">
-                <a16:creationId xmlns:a16="http://schemas.microsoft.com/office/drawing/2014/main" id="{175D54D5-CF65-4E41-BDEB-7691DF25D327}"/>
+                <a16:creationId xmlns:a16="http://schemas.microsoft.com/office/drawing/2014/main" id="{68794620-7DB1-4984-A921-FDBF93EB5991}"/>
               </a:ext>
             </a:extLst>
           </p:cNvPr>
@@ -3774,7 +3779,7 @@
         </p:nvSpPr>
         <p:spPr>
           <a:xfrm xmlns:a="http://schemas.openxmlformats.org/drawingml/2006/main">
-            <a:off x="666750" y="5657850"/>
+            <a:off x="666750" y="5133975"/>
             <a:ext cx="10477500" cy="428625"/>
           </a:xfrm>
           <a:prstGeom xmlns:a="http://schemas.openxmlformats.org/drawingml/2006/main" prst="rect">
@@ -3792,9 +3797,67 @@
           <a:lstStyle xmlns:a="http://schemas.openxmlformats.org/drawingml/2006/main"/>
           <a:p xmlns:a="http://schemas.openxmlformats.org/drawingml/2006/main">
             <a:pPr algn="l">
+              <a:defRPr sz="1800" b="0">
+                <a:solidFill>
+                  <a:srgbClr val="E9A93C"/>
+                </a:solidFill>
+                <a:latin typeface="Arial"/>
+                <a:ea typeface="Arial"/>
+                <a:cs typeface="Arial"/>
+              </a:defRPr>
+            </a:pPr>
+            <a:r>
+              <a:rPr sz="1800" b="0">
+                <a:solidFill>
+                  <a:srgbClr val="E9A93C"/>
+                </a:solidFill>
+                <a:latin typeface="Arial"/>
+                <a:ea typeface="Arial"/>
+                <a:cs typeface="Arial"/>
+                <a:hlinkClick xmlns:r="http://schemas.openxmlformats.org/officeDocument/2006/relationships" r:id="R68155a04dc844d31"/>
+              </a:rPr>
+              <a:t>MP4 : pipeline et inspection PDO</a:t>
+            </a:r>
+          </a:p>
+        </p:txBody>
+      </p:sp>
+      <p:sp>
+        <p:nvSpPr>
+          <p:cNvPr id="9" name="link-pdf">
+            <a:extLst xmlns:a="http://schemas.openxmlformats.org/drawingml/2006/main">
+              <a:ext uri="{FF2B5EF4-FFF2-40B4-BE49-F238E27FC236}">
+                <a16:creationId xmlns:a16="http://schemas.microsoft.com/office/drawing/2014/main" id="{F664D617-82D4-4AF6-800D-5A6541AE0606}"/>
+              </a:ext>
+            </a:extLst>
+          </p:cNvPr>
+          <p:cNvSpPr>
+            <a:spLocks xmlns:a="http://schemas.openxmlformats.org/drawingml/2006/main" noGrp="1"/>
+          </p:cNvSpPr>
+          <p:nvPr/>
+        </p:nvSpPr>
+        <p:spPr>
+          <a:xfrm xmlns:a="http://schemas.openxmlformats.org/drawingml/2006/main">
+            <a:off x="666750" y="5610225"/>
+            <a:ext cx="10477500" cy="428625"/>
+          </a:xfrm>
+          <a:prstGeom xmlns:a="http://schemas.openxmlformats.org/drawingml/2006/main" prst="rect">
+            <a:avLst/>
+          </a:prstGeom>
+          <a:noFill xmlns:a="http://schemas.openxmlformats.org/drawingml/2006/main"/>
+          <a:ln xmlns:a="http://schemas.openxmlformats.org/drawingml/2006/main" w="0">
+            <a:noFill/>
+          </a:ln>
+        </p:spPr>
+        <p:txBody>
+          <a:bodyPr xmlns:a="http://schemas.openxmlformats.org/drawingml/2006/main" wrap="square" lIns="0" tIns="0" rIns="0" bIns="0" anchor="ctr">
+            <a:noAutofit/>
+          </a:bodyPr>
+          <a:lstStyle xmlns:a="http://schemas.openxmlformats.org/drawingml/2006/main"/>
+          <a:p xmlns:a="http://schemas.openxmlformats.org/drawingml/2006/main">
+            <a:pPr algn="l">
               <a:defRPr sz="1650" b="0">
                 <a:solidFill>
-                  <a:srgbClr val="8BE0C9"/>
+                  <a:srgbClr val="E9A93C"/>
                 </a:solidFill>
                 <a:latin typeface="Arial"/>
                 <a:ea typeface="Arial"/>
@@ -3804,12 +3867,12 @@
             <a:r>
               <a:rPr sz="1650" b="0">
                 <a:solidFill>
-                  <a:srgbClr val="8BE0C9"/>
-                </a:solidFill>
-                <a:latin typeface="Arial"/>
-                <a:ea typeface="Arial"/>
-                <a:cs typeface="Arial"/>
-                <a:hlinkClick xmlns:r="http://schemas.openxmlformats.org/officeDocument/2006/relationships" r:id="R105667e6c1c44490"/>
+                  <a:srgbClr val="E9A93C"/>
+                </a:solidFill>
+                <a:latin typeface="Arial"/>
+                <a:ea typeface="Arial"/>
+                <a:cs typeface="Arial"/>
+                <a:hlinkClick xmlns:r="http://schemas.openxmlformats.org/officeDocument/2006/relationships" r:id="Rd3ecb936dac14f51"/>
               </a:rPr>
               <a:t>Exemple : note d’arbitrage PDF (A4)</a:t>
             </a:r>
@@ -3819,7 +3882,7 @@
     </p:spTree>
     <p:extLst>
       <p:ext uri="{BB962C8B-B14F-4D97-AF65-F5344CB8AC3E}">
-        <p14:creationId xmlns:p14="http://schemas.microsoft.com/office/powerpoint/2010/main" val="1798644169"/>
+        <p14:creationId xmlns:p14="http://schemas.microsoft.com/office/powerpoint/2010/main" val="881589743"/>
       </p:ext>
     </p:extLst>
   </p:cSld>
@@ -3850,7 +3913,7 @@
           <p:cNvPr id="5" name="title-2">
             <a:extLst xmlns:a="http://schemas.openxmlformats.org/drawingml/2006/main">
               <a:ext uri="{FF2B5EF4-FFF2-40B4-BE49-F238E27FC236}">
-                <a16:creationId xmlns:a16="http://schemas.microsoft.com/office/drawing/2014/main" id="{EB22A6DE-95C3-4292-8DD1-A58BB9422F5C}"/>
+                <a16:creationId xmlns:a16="http://schemas.microsoft.com/office/drawing/2014/main" id="{03C0A25D-F4DD-486D-8BE9-936195D68058}"/>
               </a:ext>
             </a:extLst>
           </p:cNvPr>
@@ -3897,7 +3960,7 @@
                 <a:ea typeface="Arial"/>
                 <a:cs typeface="Arial"/>
               </a:rPr>
-              <a:t>Le mini-produit : Radar des cas d’usage IA</a:t>
+              <a:t>Quel cas d’usage IA prioriseriez-vous ?</a:t>
             </a:r>
           </a:p>
         </p:txBody>
@@ -3907,7 +3970,7 @@
           <p:cNvPr id="2" name="page-2">
             <a:extLst xmlns:a="http://schemas.openxmlformats.org/drawingml/2006/main">
               <a:ext uri="{FF2B5EF4-FFF2-40B4-BE49-F238E27FC236}">
-                <a16:creationId xmlns:a16="http://schemas.microsoft.com/office/drawing/2014/main" id="{AC2D70FC-8CE2-4B16-86EC-1EE5FECBC282}"/>
+                <a16:creationId xmlns:a16="http://schemas.microsoft.com/office/drawing/2014/main" id="{7F282459-D5A5-4E20-9F51-86BF96AB0C39}"/>
               </a:ext>
             </a:extLst>
           </p:cNvPr>
@@ -3968,7 +4031,7 @@
           <p:nvPr/>
         </p:nvPicPr>
         <p:blipFill>
-          <a:blip xmlns:r="http://schemas.openxmlformats.org/officeDocument/2006/relationships" xmlns:a="http://schemas.openxmlformats.org/drawingml/2006/main" r:embed="R29d9c8d84e534a6d"/>
+          <a:blip xmlns:r="http://schemas.openxmlformats.org/officeDocument/2006/relationships" xmlns:a="http://schemas.openxmlformats.org/drawingml/2006/main" r:embed="Rb8e58b65aa3b45b5"/>
           <a:stretch xmlns:a="http://schemas.openxmlformats.org/drawingml/2006/main"/>
         </p:blipFill>
         <p:spPr>
@@ -3986,7 +4049,7 @@
           <p:cNvPr id="4" name="fiction-note">
             <a:extLst xmlns:a="http://schemas.openxmlformats.org/drawingml/2006/main">
               <a:ext uri="{FF2B5EF4-FFF2-40B4-BE49-F238E27FC236}">
-                <a16:creationId xmlns:a16="http://schemas.microsoft.com/office/drawing/2014/main" id="{4A20EAB7-5C9A-4E92-BB1A-D94CF8B91FCE}"/>
+                <a16:creationId xmlns:a16="http://schemas.microsoft.com/office/drawing/2014/main" id="{BFE2F798-D32A-4238-A0F3-88C16F1BE26D}"/>
               </a:ext>
             </a:extLst>
           </p:cNvPr>
@@ -4041,7 +4104,7 @@
     </p:spTree>
     <p:extLst>
       <p:ext uri="{BB962C8B-B14F-4D97-AF65-F5344CB8AC3E}">
-        <p14:creationId xmlns:p14="http://schemas.microsoft.com/office/powerpoint/2010/main" val="884447947"/>
+        <p14:creationId xmlns:p14="http://schemas.microsoft.com/office/powerpoint/2010/main" val="426329777"/>
       </p:ext>
     </p:extLst>
   </p:cSld>
@@ -4072,7 +4135,7 @@
           <p:cNvPr id="7" name="title-3">
             <a:extLst xmlns:a="http://schemas.openxmlformats.org/drawingml/2006/main">
               <a:ext uri="{FF2B5EF4-FFF2-40B4-BE49-F238E27FC236}">
-                <a16:creationId xmlns:a16="http://schemas.microsoft.com/office/drawing/2014/main" id="{6A412FE1-4092-45F8-9366-956CAE61040E}"/>
+                <a16:creationId xmlns:a16="http://schemas.microsoft.com/office/drawing/2014/main" id="{DCA7549F-9855-4749-8A5E-C85069F15F33}"/>
               </a:ext>
             </a:extLst>
           </p:cNvPr>
@@ -4119,7 +4182,7 @@
                 <a:ea typeface="Arial"/>
                 <a:cs typeface="Arial"/>
               </a:rPr>
-              <a:t>PDSF : une méthode installée dans le dépôt</a:t>
+              <a:t>PDSF : clarifier la demande dans le dépôt</a:t>
             </a:r>
           </a:p>
         </p:txBody>
@@ -4129,7 +4192,7 @@
           <p:cNvPr id="2" name="page-3">
             <a:extLst xmlns:a="http://schemas.openxmlformats.org/drawingml/2006/main">
               <a:ext uri="{FF2B5EF4-FFF2-40B4-BE49-F238E27FC236}">
-                <a16:creationId xmlns:a16="http://schemas.microsoft.com/office/drawing/2014/main" id="{A024F8D9-4E31-4E11-9E49-E26EF5CDAFF8}"/>
+                <a16:creationId xmlns:a16="http://schemas.microsoft.com/office/drawing/2014/main" id="{05D54369-EE55-4077-89F6-F3F0C1EDD753}"/>
               </a:ext>
             </a:extLst>
           </p:cNvPr>
@@ -4186,7 +4249,7 @@
           <p:cNvPr id="3" name="pdsf-definition">
             <a:extLst xmlns:a="http://schemas.openxmlformats.org/drawingml/2006/main">
               <a:ext uri="{FF2B5EF4-FFF2-40B4-BE49-F238E27FC236}">
-                <a16:creationId xmlns:a16="http://schemas.microsoft.com/office/drawing/2014/main" id="{0281EA6D-C932-46EB-8687-D52F458C4E87}"/>
+                <a16:creationId xmlns:a16="http://schemas.microsoft.com/office/drawing/2014/main" id="{92456E96-52B0-4F9A-9DF7-13B06789EE88}"/>
               </a:ext>
             </a:extLst>
           </p:cNvPr>
@@ -4243,7 +4306,7 @@
           <p:cNvPr id="4" name="pdsf-files">
             <a:extLst xmlns:a="http://schemas.openxmlformats.org/drawingml/2006/main">
               <a:ext uri="{FF2B5EF4-FFF2-40B4-BE49-F238E27FC236}">
-                <a16:creationId xmlns:a16="http://schemas.microsoft.com/office/drawing/2014/main" id="{73F19702-7EB8-4774-ADEB-CBE9FB8883F0}"/>
+                <a16:creationId xmlns:a16="http://schemas.microsoft.com/office/drawing/2014/main" id="{FE1C36A7-47DD-4549-AE4F-AF06D57EF50D}"/>
               </a:ext>
             </a:extLst>
           </p:cNvPr>
@@ -4369,7 +4432,7 @@
           <p:cNvPr id="5" name="pdsf-bootstrap">
             <a:extLst xmlns:a="http://schemas.openxmlformats.org/drawingml/2006/main">
               <a:ext uri="{FF2B5EF4-FFF2-40B4-BE49-F238E27FC236}">
-                <a16:creationId xmlns:a16="http://schemas.microsoft.com/office/drawing/2014/main" id="{4A7593AD-B48C-4B72-BC46-074E0F29A91D}"/>
+                <a16:creationId xmlns:a16="http://schemas.microsoft.com/office/drawing/2014/main" id="{E3B3264B-54F7-4B6F-B91D-95962910575C}"/>
               </a:ext>
             </a:extLst>
           </p:cNvPr>
@@ -4449,7 +4512,7 @@
           <p:cNvPr id="6" name="pdsf-qualification">
             <a:extLst xmlns:a="http://schemas.openxmlformats.org/drawingml/2006/main">
               <a:ext uri="{FF2B5EF4-FFF2-40B4-BE49-F238E27FC236}">
-                <a16:creationId xmlns:a16="http://schemas.microsoft.com/office/drawing/2014/main" id="{1C267749-511D-416A-A102-CD0617C111D2}"/>
+                <a16:creationId xmlns:a16="http://schemas.microsoft.com/office/drawing/2014/main" id="{6B04834D-E1FE-4061-8DB3-CCD91501A3ED}"/>
               </a:ext>
             </a:extLst>
           </p:cNvPr>
@@ -4504,7 +4567,7 @@
     </p:spTree>
     <p:extLst>
       <p:ext uri="{BB962C8B-B14F-4D97-AF65-F5344CB8AC3E}">
-        <p14:creationId xmlns:p14="http://schemas.microsoft.com/office/powerpoint/2010/main" val="1008307453"/>
+        <p14:creationId xmlns:p14="http://schemas.microsoft.com/office/powerpoint/2010/main" val="1735882646"/>
       </p:ext>
     </p:extLst>
   </p:cSld>
@@ -4532,10 +4595,10 @@
       </p:grpSpPr>
       <p:sp>
         <p:nvSpPr>
-          <p:cNvPr id="7" name="title-4">
+          <p:cNvPr id="6" name="title-4">
             <a:extLst xmlns:a="http://schemas.openxmlformats.org/drawingml/2006/main">
               <a:ext uri="{FF2B5EF4-FFF2-40B4-BE49-F238E27FC236}">
-                <a16:creationId xmlns:a16="http://schemas.microsoft.com/office/drawing/2014/main" id="{C0F7A9FF-7F6D-4461-A1E8-9AD900CC4B66}"/>
+                <a16:creationId xmlns:a16="http://schemas.microsoft.com/office/drawing/2014/main" id="{58B34FE5-9364-4A54-823A-01554ABBB5B8}"/>
               </a:ext>
             </a:extLst>
           </p:cNvPr>
@@ -4582,7 +4645,7 @@
                 <a:ea typeface="Arial"/>
                 <a:cs typeface="Arial"/>
               </a:rPr>
-              <a:t>PDSF : du backlog métier au ticket exploitable</a:t>
+              <a:t>Avant le code : deux questions métier</a:t>
             </a:r>
           </a:p>
         </p:txBody>
@@ -4592,7 +4655,7 @@
           <p:cNvPr id="2" name="page-4">
             <a:extLst xmlns:a="http://schemas.openxmlformats.org/drawingml/2006/main">
               <a:ext uri="{FF2B5EF4-FFF2-40B4-BE49-F238E27FC236}">
-                <a16:creationId xmlns:a16="http://schemas.microsoft.com/office/drawing/2014/main" id="{F866C4B0-0986-4BCB-BFC3-B4F53909242D}"/>
+                <a16:creationId xmlns:a16="http://schemas.microsoft.com/office/drawing/2014/main" id="{070F339C-A1DC-4BBB-A8DF-4E759C2BDF4D}"/>
               </a:ext>
             </a:extLst>
           </p:cNvPr>
@@ -4646,10 +4709,10 @@
       </p:sp>
       <p:sp>
         <p:nvSpPr>
-          <p:cNvPr id="3" name="step-01">
+          <p:cNvPr id="3" name="question-01">
             <a:extLst xmlns:a="http://schemas.openxmlformats.org/drawingml/2006/main">
               <a:ext uri="{FF2B5EF4-FFF2-40B4-BE49-F238E27FC236}">
-                <a16:creationId xmlns:a16="http://schemas.microsoft.com/office/drawing/2014/main" id="{0217D7ED-1A33-4656-BF00-D05F657EBA8D}"/>
+                <a16:creationId xmlns:a16="http://schemas.microsoft.com/office/drawing/2014/main" id="{6C4F3240-B2DB-4F33-BA29-24368D993B39}"/>
               </a:ext>
             </a:extLst>
           </p:cNvPr>
@@ -4660,8 +4723,8 @@
         </p:nvSpPr>
         <p:spPr>
           <a:xfrm xmlns:a="http://schemas.openxmlformats.org/drawingml/2006/main">
-            <a:off x="723900" y="1552575"/>
-            <a:ext cx="10382250" cy="676275"/>
+            <a:off x="723900" y="1714500"/>
+            <a:ext cx="10382250" cy="762000"/>
           </a:xfrm>
           <a:prstGeom xmlns:a="http://schemas.openxmlformats.org/drawingml/2006/main" prst="rect">
             <a:avLst/>
@@ -4678,7 +4741,7 @@
           <a:lstStyle xmlns:a="http://schemas.openxmlformats.org/drawingml/2006/main"/>
           <a:p xmlns:a="http://schemas.openxmlformats.org/drawingml/2006/main">
             <a:pPr algn="l">
-              <a:defRPr sz="2475" b="1">
+              <a:defRPr sz="2775" b="1">
                 <a:solidFill>
                   <a:srgbClr val="0B604F"/>
                 </a:solidFill>
@@ -4688,7 +4751,7 @@
               </a:defRPr>
             </a:pPr>
             <a:r>
-              <a:rPr sz="2475" b="1">
+              <a:rPr sz="2775" b="1">
                 <a:solidFill>
                   <a:srgbClr val="0B604F"/>
                 </a:solidFill>
@@ -4696,17 +4759,17 @@
                 <a:ea typeface="Arial"/>
                 <a:cs typeface="Arial"/>
               </a:rPr>
-              <a:t>01   Besoin métier et User Stories</a:t>
-            </a:r>
-          </a:p>
-        </p:txBody>
-      </p:sp>
-      <p:sp>
-        <p:nvSpPr>
-          <p:cNvPr id="4" name="step-02">
+              <a:t>À quelle décision servira la note ?</a:t>
+            </a:r>
+          </a:p>
+        </p:txBody>
+      </p:sp>
+      <p:sp>
+        <p:nvSpPr>
+          <p:cNvPr id="4" name="question-02">
             <a:extLst xmlns:a="http://schemas.openxmlformats.org/drawingml/2006/main">
               <a:ext uri="{FF2B5EF4-FFF2-40B4-BE49-F238E27FC236}">
-                <a16:creationId xmlns:a16="http://schemas.microsoft.com/office/drawing/2014/main" id="{15C5B03D-DDCF-4ED3-998F-2EF459320D44}"/>
+                <a16:creationId xmlns:a16="http://schemas.microsoft.com/office/drawing/2014/main" id="{C8D7ABEC-6394-4B6F-9109-14FC56B09F8B}"/>
               </a:ext>
             </a:extLst>
           </p:cNvPr>
@@ -4717,8 +4780,8 @@
         </p:nvSpPr>
         <p:spPr>
           <a:xfrm xmlns:a="http://schemas.openxmlformats.org/drawingml/2006/main">
-            <a:off x="723900" y="2600325"/>
-            <a:ext cx="10382250" cy="819150"/>
+            <a:off x="723900" y="3171825"/>
+            <a:ext cx="10382250" cy="962025"/>
           </a:xfrm>
           <a:prstGeom xmlns:a="http://schemas.openxmlformats.org/drawingml/2006/main" prst="rect">
             <a:avLst/>
@@ -4735,7 +4798,7 @@
           <a:lstStyle xmlns:a="http://schemas.openxmlformats.org/drawingml/2006/main"/>
           <a:p xmlns:a="http://schemas.openxmlformats.org/drawingml/2006/main">
             <a:pPr algn="l">
-              <a:defRPr sz="2475" b="1">
+              <a:defRPr sz="2775" b="1">
                 <a:solidFill>
                   <a:srgbClr val="14202B"/>
                 </a:solidFill>
@@ -4745,7 +4808,7 @@
               </a:defRPr>
             </a:pPr>
             <a:r>
-              <a:rPr sz="2475" b="1">
+              <a:rPr sz="2775" b="1">
                 <a:solidFill>
                   <a:srgbClr val="14202B"/>
                 </a:solidFill>
@@ -4753,17 +4816,17 @@
                 <a:ea typeface="Arial"/>
                 <a:cs typeface="Arial"/>
               </a:rPr>
-              <a:t>02   Conception : vocabulaire, décisions, critères</a:t>
-            </a:r>
-          </a:p>
-        </p:txBody>
-      </p:sp>
-      <p:sp>
-        <p:nvSpPr>
-          <p:cNvPr id="5" name="step-03">
+              <a:t>Quelle preuve attend-on si un score change ?</a:t>
+            </a:r>
+          </a:p>
+        </p:txBody>
+      </p:sp>
+      <p:sp>
+        <p:nvSpPr>
+          <p:cNvPr id="5" name="pdsf-transition">
             <a:extLst xmlns:a="http://schemas.openxmlformats.org/drawingml/2006/main">
               <a:ext uri="{FF2B5EF4-FFF2-40B4-BE49-F238E27FC236}">
-                <a16:creationId xmlns:a16="http://schemas.microsoft.com/office/drawing/2014/main" id="{3606AD21-EB09-4CB6-9EF9-E00A2D2001F7}"/>
+                <a16:creationId xmlns:a16="http://schemas.microsoft.com/office/drawing/2014/main" id="{987345F8-15AD-4641-AE02-836AD0E000F3}"/>
               </a:ext>
             </a:extLst>
           </p:cNvPr>
@@ -4774,8 +4837,8 @@
         </p:nvSpPr>
         <p:spPr>
           <a:xfrm xmlns:a="http://schemas.openxmlformats.org/drawingml/2006/main">
-            <a:off x="723900" y="3876675"/>
-            <a:ext cx="10382250" cy="809625"/>
+            <a:off x="723900" y="5286375"/>
+            <a:ext cx="10477500" cy="876300"/>
           </a:xfrm>
           <a:prstGeom xmlns:a="http://schemas.openxmlformats.org/drawingml/2006/main" prst="rect">
             <a:avLst/>
@@ -4792,64 +4855,7 @@
           <a:lstStyle xmlns:a="http://schemas.openxmlformats.org/drawingml/2006/main"/>
           <a:p xmlns:a="http://schemas.openxmlformats.org/drawingml/2006/main">
             <a:pPr algn="l">
-              <a:defRPr sz="2475" b="1">
-                <a:solidFill>
-                  <a:srgbClr val="14202B"/>
-                </a:solidFill>
-                <a:latin typeface="Arial"/>
-                <a:ea typeface="Arial"/>
-                <a:cs typeface="Arial"/>
-              </a:defRPr>
-            </a:pPr>
-            <a:r>
-              <a:rPr sz="2475" b="1">
-                <a:solidFill>
-                  <a:srgbClr val="14202B"/>
-                </a:solidFill>
-                <a:latin typeface="Arial"/>
-                <a:ea typeface="Arial"/>
-                <a:cs typeface="Arial"/>
-              </a:rPr>
-              <a:t>03   Spec et tickets techniques autoporteurs</a:t>
-            </a:r>
-          </a:p>
-        </p:txBody>
-      </p:sp>
-      <p:sp>
-        <p:nvSpPr>
-          <p:cNvPr id="6" name="pdsf-humans">
-            <a:extLst xmlns:a="http://schemas.openxmlformats.org/drawingml/2006/main">
-              <a:ext uri="{FF2B5EF4-FFF2-40B4-BE49-F238E27FC236}">
-                <a16:creationId xmlns:a16="http://schemas.microsoft.com/office/drawing/2014/main" id="{2F831857-EFEF-4E8E-8CEC-8B4AC8D0EE8B}"/>
-              </a:ext>
-            </a:extLst>
-          </p:cNvPr>
-          <p:cNvSpPr>
-            <a:spLocks xmlns:a="http://schemas.openxmlformats.org/drawingml/2006/main" noGrp="1"/>
-          </p:cNvSpPr>
-          <p:nvPr/>
-        </p:nvSpPr>
-        <p:spPr>
-          <a:xfrm xmlns:a="http://schemas.openxmlformats.org/drawingml/2006/main">
-            <a:off x="723900" y="5305425"/>
-            <a:ext cx="10477500" cy="676275"/>
-          </a:xfrm>
-          <a:prstGeom xmlns:a="http://schemas.openxmlformats.org/drawingml/2006/main" prst="rect">
-            <a:avLst/>
-          </a:prstGeom>
-          <a:noFill xmlns:a="http://schemas.openxmlformats.org/drawingml/2006/main"/>
-          <a:ln xmlns:a="http://schemas.openxmlformats.org/drawingml/2006/main" w="0">
-            <a:noFill/>
-          </a:ln>
-        </p:spPr>
-        <p:txBody>
-          <a:bodyPr xmlns:a="http://schemas.openxmlformats.org/drawingml/2006/main" wrap="square" lIns="0" tIns="0" rIns="0" bIns="0" anchor="ctr">
-            <a:noAutofit/>
-          </a:bodyPr>
-          <a:lstStyle xmlns:a="http://schemas.openxmlformats.org/drawingml/2006/main"/>
-          <a:p xmlns:a="http://schemas.openxmlformats.org/drawingml/2006/main">
-            <a:pPr algn="l">
-              <a:defRPr sz="1725" b="0">
+              <a:defRPr sz="1875" b="0">
                 <a:solidFill>
                   <a:srgbClr val="65727B"/>
                 </a:solidFill>
@@ -4859,7 +4865,7 @@
               </a:defRPr>
             </a:pPr>
             <a:r>
-              <a:rPr sz="1725" b="0">
+              <a:rPr sz="1875" b="0">
                 <a:solidFill>
                   <a:srgbClr val="65727B"/>
                 </a:solidFill>
@@ -4867,7 +4873,7 @@
                 <a:ea typeface="Arial"/>
                 <a:cs typeface="Arial"/>
               </a:rPr>
-              <a:t>Le PO et le développeur gardent la main sur les décisions structurantes.</a:t>
+              <a:t>PDSF aide à transformer les réponses en contexte, critères et ticket vérifiable.</a:t>
             </a:r>
           </a:p>
         </p:txBody>
@@ -4875,7 +4881,7 @@
     </p:spTree>
     <p:extLst>
       <p:ext uri="{BB962C8B-B14F-4D97-AF65-F5344CB8AC3E}">
-        <p14:creationId xmlns:p14="http://schemas.microsoft.com/office/powerpoint/2010/main" val="1031024235"/>
+        <p14:creationId xmlns:p14="http://schemas.microsoft.com/office/powerpoint/2010/main" val="1182783600"/>
       </p:ext>
     </p:extLst>
   </p:cSld>
@@ -4906,7 +4912,7 @@
           <p:cNvPr id="7" name="title-5">
             <a:extLst xmlns:a="http://schemas.openxmlformats.org/drawingml/2006/main">
               <a:ext uri="{FF2B5EF4-FFF2-40B4-BE49-F238E27FC236}">
-                <a16:creationId xmlns:a16="http://schemas.microsoft.com/office/drawing/2014/main" id="{39CB0996-2DF3-40A0-93C6-12DE3E493BC0}"/>
+                <a16:creationId xmlns:a16="http://schemas.microsoft.com/office/drawing/2014/main" id="{EF9325ED-522F-4982-95B7-FD48F78593D3}"/>
               </a:ext>
             </a:extLst>
           </p:cNvPr>
@@ -4953,7 +4959,7 @@
                 <a:ea typeface="Arial"/>
                 <a:cs typeface="Arial"/>
               </a:rPr>
-              <a:t>L’issue de l’atelier : une note d’arbitrage</a:t>
+              <a:t>Une vraie issue : la note d’arbitrage</a:t>
             </a:r>
           </a:p>
         </p:txBody>
@@ -4963,7 +4969,7 @@
           <p:cNvPr id="2" name="page-5">
             <a:extLst xmlns:a="http://schemas.openxmlformats.org/drawingml/2006/main">
               <a:ext uri="{FF2B5EF4-FFF2-40B4-BE49-F238E27FC236}">
-                <a16:creationId xmlns:a16="http://schemas.microsoft.com/office/drawing/2014/main" id="{CE40628A-1BFA-4B5D-9DE9-72882D2D8899}"/>
+                <a16:creationId xmlns:a16="http://schemas.microsoft.com/office/drawing/2014/main" id="{C93024B2-AF68-4497-BCF7-A6101FF7F4C3}"/>
               </a:ext>
             </a:extLst>
           </p:cNvPr>
@@ -5020,7 +5026,7 @@
           <p:cNvPr id="3" name="issue-need">
             <a:extLst xmlns:a="http://schemas.openxmlformats.org/drawingml/2006/main">
               <a:ext uri="{FF2B5EF4-FFF2-40B4-BE49-F238E27FC236}">
-                <a16:creationId xmlns:a16="http://schemas.microsoft.com/office/drawing/2014/main" id="{425EC882-EF16-4DFD-BAF1-BF651A926F76}"/>
+                <a16:creationId xmlns:a16="http://schemas.microsoft.com/office/drawing/2014/main" id="{D9244CDB-33C7-4FFA-BF5B-EF5B43509AEC}"/>
               </a:ext>
             </a:extLst>
           </p:cNvPr>
@@ -5077,7 +5083,7 @@
           <p:cNvPr id="4" name="issue-criteria">
             <a:extLst xmlns:a="http://schemas.openxmlformats.org/drawingml/2006/main">
               <a:ext uri="{FF2B5EF4-FFF2-40B4-BE49-F238E27FC236}">
-                <a16:creationId xmlns:a16="http://schemas.microsoft.com/office/drawing/2014/main" id="{1CD9C130-F7A9-4D2C-8B2D-F12B59F5A716}"/>
+                <a16:creationId xmlns:a16="http://schemas.microsoft.com/office/drawing/2014/main" id="{573FCD42-2E1E-45A0-8B58-93A964081CCE}"/>
               </a:ext>
             </a:extLst>
           </p:cNvPr>
@@ -5203,7 +5209,7 @@
           <p:cNvPr id="5" name="issue-link">
             <a:extLst xmlns:a="http://schemas.openxmlformats.org/drawingml/2006/main">
               <a:ext uri="{FF2B5EF4-FFF2-40B4-BE49-F238E27FC236}">
-                <a16:creationId xmlns:a16="http://schemas.microsoft.com/office/drawing/2014/main" id="{CC32D4C1-EE1E-463C-AC63-835DDCDEA508}"/>
+                <a16:creationId xmlns:a16="http://schemas.microsoft.com/office/drawing/2014/main" id="{C8EB4DB5-934E-49CF-B683-E2C99A12EB7D}"/>
               </a:ext>
             </a:extLst>
           </p:cNvPr>
@@ -5249,7 +5255,7 @@
                 <a:latin typeface="Arial"/>
                 <a:ea typeface="Arial"/>
                 <a:cs typeface="Arial"/>
-                <a:hlinkClick xmlns:r="http://schemas.openxmlformats.org/officeDocument/2006/relationships" r:id="Ra27b36d1ab4340b0"/>
+                <a:hlinkClick xmlns:r="http://schemas.openxmlformats.org/officeDocument/2006/relationships" r:id="R2ddd58ff715a4a7c"/>
               </a:rPr>
               <a:t>GitHub issue #1</a:t>
             </a:r>
@@ -5265,7 +5271,7 @@
           <p:nvPr/>
         </p:nvPicPr>
         <p:blipFill>
-          <a:blip xmlns:r="http://schemas.openxmlformats.org/officeDocument/2006/relationships" xmlns:a="http://schemas.openxmlformats.org/drawingml/2006/main" r:embed="R4f81af9211254033"/>
+          <a:blip xmlns:r="http://schemas.openxmlformats.org/officeDocument/2006/relationships" xmlns:a="http://schemas.openxmlformats.org/drawingml/2006/main" r:embed="Ra03ba64b90224dbd"/>
           <a:stretch xmlns:a="http://schemas.openxmlformats.org/drawingml/2006/main"/>
         </p:blipFill>
         <p:spPr>
@@ -5281,7 +5287,7 @@
     </p:spTree>
     <p:extLst>
       <p:ext uri="{BB962C8B-B14F-4D97-AF65-F5344CB8AC3E}">
-        <p14:creationId xmlns:p14="http://schemas.microsoft.com/office/powerpoint/2010/main" val="1971493608"/>
+        <p14:creationId xmlns:p14="http://schemas.microsoft.com/office/powerpoint/2010/main" val="1254614231"/>
       </p:ext>
     </p:extLst>
   </p:cSld>
@@ -5312,7 +5318,7 @@
           <p:cNvPr id="7" name="title-6">
             <a:extLst xmlns:a="http://schemas.openxmlformats.org/drawingml/2006/main">
               <a:ext uri="{FF2B5EF4-FFF2-40B4-BE49-F238E27FC236}">
-                <a16:creationId xmlns:a16="http://schemas.microsoft.com/office/drawing/2014/main" id="{D80E7EC8-DC9E-4E96-84CB-D0086B2A0438}"/>
+                <a16:creationId xmlns:a16="http://schemas.microsoft.com/office/drawing/2014/main" id="{17E2271E-C18F-42CF-8726-B3AB664ADF2C}"/>
               </a:ext>
             </a:extLst>
           </p:cNvPr>
@@ -5359,7 +5365,7 @@
                 <a:ea typeface="Arial"/>
                 <a:cs typeface="Arial"/>
               </a:rPr>
-              <a:t>PDO : un pipeline réutilisable, un run par dépôt</a:t>
+              <a:t>PDO : un pipeline, un run, des preuves</a:t>
             </a:r>
           </a:p>
         </p:txBody>
@@ -5369,7 +5375,7 @@
           <p:cNvPr id="2" name="page-6">
             <a:extLst xmlns:a="http://schemas.openxmlformats.org/drawingml/2006/main">
               <a:ext uri="{FF2B5EF4-FFF2-40B4-BE49-F238E27FC236}">
-                <a16:creationId xmlns:a16="http://schemas.microsoft.com/office/drawing/2014/main" id="{E26F3AF7-EE16-40A9-A9BD-B2F374E90D4F}"/>
+                <a16:creationId xmlns:a16="http://schemas.microsoft.com/office/drawing/2014/main" id="{B5184D3E-5E8C-43A9-B72C-C4252FE30334}"/>
               </a:ext>
             </a:extLst>
           </p:cNvPr>
@@ -5426,7 +5432,7 @@
           <p:cNvPr id="3" name="pdo-concept-1">
             <a:extLst xmlns:a="http://schemas.openxmlformats.org/drawingml/2006/main">
               <a:ext uri="{FF2B5EF4-FFF2-40B4-BE49-F238E27FC236}">
-                <a16:creationId xmlns:a16="http://schemas.microsoft.com/office/drawing/2014/main" id="{7F5B3F96-4AED-4634-9412-0190F831A336}"/>
+                <a16:creationId xmlns:a16="http://schemas.microsoft.com/office/drawing/2014/main" id="{1E51AADF-1328-4806-8DC9-6063C296DF8D}"/>
               </a:ext>
             </a:extLst>
           </p:cNvPr>
@@ -5483,7 +5489,7 @@
           <p:cNvPr id="4" name="pdo-concept-2">
             <a:extLst xmlns:a="http://schemas.openxmlformats.org/drawingml/2006/main">
               <a:ext uri="{FF2B5EF4-FFF2-40B4-BE49-F238E27FC236}">
-                <a16:creationId xmlns:a16="http://schemas.microsoft.com/office/drawing/2014/main" id="{43C0C5C8-00E1-45A7-91E1-10A4E0B1681D}"/>
+                <a16:creationId xmlns:a16="http://schemas.microsoft.com/office/drawing/2014/main" id="{417D1593-C924-4407-89F8-8B3D74F19A6D}"/>
               </a:ext>
             </a:extLst>
           </p:cNvPr>
@@ -5540,7 +5546,7 @@
           <p:cNvPr id="5" name="pdo-concept-3">
             <a:extLst xmlns:a="http://schemas.openxmlformats.org/drawingml/2006/main">
               <a:ext uri="{FF2B5EF4-FFF2-40B4-BE49-F238E27FC236}">
-                <a16:creationId xmlns:a16="http://schemas.microsoft.com/office/drawing/2014/main" id="{1BC358E9-C0F1-4A0D-9601-B75EF0AB7399}"/>
+                <a16:creationId xmlns:a16="http://schemas.microsoft.com/office/drawing/2014/main" id="{37328F5E-7469-455A-8C87-D4483E875D5C}"/>
               </a:ext>
             </a:extLst>
           </p:cNvPr>
@@ -5594,10 +5600,10 @@
       </p:sp>
       <p:sp>
         <p:nvSpPr>
-          <p:cNvPr id="6" name="pdo-caution">
+          <p:cNvPr id="6" name="pdo-question">
             <a:extLst xmlns:a="http://schemas.openxmlformats.org/drawingml/2006/main">
               <a:ext uri="{FF2B5EF4-FFF2-40B4-BE49-F238E27FC236}">
-                <a16:creationId xmlns:a16="http://schemas.microsoft.com/office/drawing/2014/main" id="{EBFB0741-CA8D-4516-9B45-4188548C35B9}"/>
+                <a16:creationId xmlns:a16="http://schemas.microsoft.com/office/drawing/2014/main" id="{85573428-6BE1-4C23-9038-997E2393373C}"/>
               </a:ext>
             </a:extLst>
           </p:cNvPr>
@@ -5608,8 +5614,8 @@
         </p:nvSpPr>
         <p:spPr>
           <a:xfrm xmlns:a="http://schemas.openxmlformats.org/drawingml/2006/main">
-            <a:off x="666750" y="5543550"/>
-            <a:ext cx="10477500" cy="571500"/>
+            <a:off x="666750" y="5476875"/>
+            <a:ext cx="10572750" cy="762000"/>
           </a:xfrm>
           <a:prstGeom xmlns:a="http://schemas.openxmlformats.org/drawingml/2006/main" prst="rect">
             <a:avLst/>
@@ -5626,25 +5632,25 @@
           <a:lstStyle xmlns:a="http://schemas.openxmlformats.org/drawingml/2006/main"/>
           <a:p xmlns:a="http://schemas.openxmlformats.org/drawingml/2006/main">
             <a:pPr algn="l">
-              <a:defRPr sz="1575" b="0">
-                <a:solidFill>
-                  <a:srgbClr val="B8CBC7"/>
-                </a:solidFill>
-                <a:latin typeface="Arial"/>
-                <a:ea typeface="Arial"/>
-                <a:cs typeface="Arial"/>
-              </a:defRPr>
-            </a:pPr>
-            <a:r>
-              <a:rPr sz="1575" b="0">
-                <a:solidFill>
-                  <a:srgbClr val="B8CBC7"/>
-                </a:solidFill>
-                <a:latin typeface="Arial"/>
-                <a:ea typeface="Arial"/>
-                <a:cs typeface="Arial"/>
-              </a:rPr>
-              <a:t>PDSF et PDO sont complémentaires. Aucun des deux n’installe l’autre automatiquement.</a:t>
+              <a:defRPr sz="1725" b="0">
+                <a:solidFill>
+                  <a:srgbClr val="E9A93C"/>
+                </a:solidFill>
+                <a:latin typeface="Arial"/>
+                <a:ea typeface="Arial"/>
+                <a:cs typeface="Arial"/>
+              </a:defRPr>
+            </a:pPr>
+            <a:r>
+              <a:rPr sz="1725" b="0">
+                <a:solidFill>
+                  <a:srgbClr val="E9A93C"/>
+                </a:solidFill>
+                <a:latin typeface="Arial"/>
+                <a:ea typeface="Arial"/>
+                <a:cs typeface="Arial"/>
+              </a:rPr>
+              <a:t>À votre avis : qui vérifie le résultat, et que faire si la revue échoue ?</a:t>
             </a:r>
           </a:p>
         </p:txBody>
@@ -5652,7 +5658,7 @@
     </p:spTree>
     <p:extLst>
       <p:ext uri="{BB962C8B-B14F-4D97-AF65-F5344CB8AC3E}">
-        <p14:creationId xmlns:p14="http://schemas.microsoft.com/office/powerpoint/2010/main" val="2110471785"/>
+        <p14:creationId xmlns:p14="http://schemas.microsoft.com/office/powerpoint/2010/main" val="2041909737"/>
       </p:ext>
     </p:extLst>
   </p:cSld>
@@ -5683,7 +5689,7 @@
           <p:cNvPr id="9" name="title-7">
             <a:extLst xmlns:a="http://schemas.openxmlformats.org/drawingml/2006/main">
               <a:ext uri="{FF2B5EF4-FFF2-40B4-BE49-F238E27FC236}">
-                <a16:creationId xmlns:a16="http://schemas.microsoft.com/office/drawing/2014/main" id="{0ADECDF6-6FE6-461D-A59D-FBCB27F43F37}"/>
+                <a16:creationId xmlns:a16="http://schemas.microsoft.com/office/drawing/2014/main" id="{1E28E311-C4E9-4BFE-B9DA-814D99236BAA}"/>
               </a:ext>
             </a:extLst>
           </p:cNvPr>
@@ -5730,7 +5736,7 @@
                 <a:ea typeface="Arial"/>
                 <a:cs typeface="Arial"/>
               </a:rPr>
-              <a:t>Pipeline Radar IA : une revue avec boucle bornée</a:t>
+              <a:t>Le vrai pipeline : retour limité en cas d’échec</a:t>
             </a:r>
           </a:p>
         </p:txBody>
@@ -5740,7 +5746,7 @@
           <p:cNvPr id="2" name="page-7">
             <a:extLst xmlns:a="http://schemas.openxmlformats.org/drawingml/2006/main">
               <a:ext uri="{FF2B5EF4-FFF2-40B4-BE49-F238E27FC236}">
-                <a16:creationId xmlns:a16="http://schemas.microsoft.com/office/drawing/2014/main" id="{1BFF744C-0DA9-4D0E-9184-D2794ADE9FD2}"/>
+                <a16:creationId xmlns:a16="http://schemas.microsoft.com/office/drawing/2014/main" id="{824AFDB2-F7F3-48DA-8F83-1FDCAB506B61}"/>
               </a:ext>
             </a:extLst>
           </p:cNvPr>
@@ -5801,7 +5807,7 @@
           <p:nvPr/>
         </p:nvPicPr>
         <p:blipFill>
-          <a:blip xmlns:r="http://schemas.openxmlformats.org/officeDocument/2006/relationships" xmlns:a="http://schemas.openxmlformats.org/drawingml/2006/main" r:embed="Rb4c9ce73f92b4055"/>
+          <a:blip xmlns:r="http://schemas.openxmlformats.org/officeDocument/2006/relationships" xmlns:a="http://schemas.openxmlformats.org/drawingml/2006/main" r:embed="R879703f975be498b"/>
           <a:stretch xmlns:a="http://schemas.openxmlformats.org/drawingml/2006/main"/>
         </p:blipFill>
         <p:spPr>
@@ -5819,7 +5825,7 @@
           <p:cNvPr id="4" name="pipeline-read">
             <a:extLst xmlns:a="http://schemas.openxmlformats.org/drawingml/2006/main">
               <a:ext uri="{FF2B5EF4-FFF2-40B4-BE49-F238E27FC236}">
-                <a16:creationId xmlns:a16="http://schemas.microsoft.com/office/drawing/2014/main" id="{B07C80A4-46E6-4D5C-A943-9E8AB5B5EE61}"/>
+                <a16:creationId xmlns:a16="http://schemas.microsoft.com/office/drawing/2014/main" id="{8BDF74DA-E97E-4281-BC4B-594A2E9C7C97}"/>
               </a:ext>
             </a:extLst>
           </p:cNvPr>
@@ -5899,7 +5905,7 @@
           <p:cNvPr id="5" name="pipeline-build">
             <a:extLst xmlns:a="http://schemas.openxmlformats.org/drawingml/2006/main">
               <a:ext uri="{FF2B5EF4-FFF2-40B4-BE49-F238E27FC236}">
-                <a16:creationId xmlns:a16="http://schemas.microsoft.com/office/drawing/2014/main" id="{B9F38CEC-B84D-4250-AB0B-C822AB3532A0}"/>
+                <a16:creationId xmlns:a16="http://schemas.microsoft.com/office/drawing/2014/main" id="{767CA105-166A-4203-BA25-C6C863334296}"/>
               </a:ext>
             </a:extLst>
           </p:cNvPr>
@@ -5979,7 +5985,7 @@
           <p:cNvPr id="6" name="pipeline-review">
             <a:extLst xmlns:a="http://schemas.openxmlformats.org/drawingml/2006/main">
               <a:ext uri="{FF2B5EF4-FFF2-40B4-BE49-F238E27FC236}">
-                <a16:creationId xmlns:a16="http://schemas.microsoft.com/office/drawing/2014/main" id="{AC4D8C33-B7B4-402F-B23E-E196A76ADC28}"/>
+                <a16:creationId xmlns:a16="http://schemas.microsoft.com/office/drawing/2014/main" id="{A6EC5DF4-95AA-416D-AB5D-5588DE9B419B}"/>
               </a:ext>
             </a:extLst>
           </p:cNvPr>
@@ -6059,7 +6065,7 @@
           <p:cNvPr id="7" name="pipeline-brief">
             <a:extLst xmlns:a="http://schemas.openxmlformats.org/drawingml/2006/main">
               <a:ext uri="{FF2B5EF4-FFF2-40B4-BE49-F238E27FC236}">
-                <a16:creationId xmlns:a16="http://schemas.microsoft.com/office/drawing/2014/main" id="{AF14579C-CE82-47B9-9C33-53EBADCC3C5E}"/>
+                <a16:creationId xmlns:a16="http://schemas.microsoft.com/office/drawing/2014/main" id="{C18383C6-E0B8-474D-9F8D-4AA9F8FB31D4}"/>
               </a:ext>
             </a:extLst>
           </p:cNvPr>
@@ -6139,7 +6145,7 @@
           <p:cNvPr id="8" name="pipeline-branch">
             <a:extLst xmlns:a="http://schemas.openxmlformats.org/drawingml/2006/main">
               <a:ext uri="{FF2B5EF4-FFF2-40B4-BE49-F238E27FC236}">
-                <a16:creationId xmlns:a16="http://schemas.microsoft.com/office/drawing/2014/main" id="{8A104535-E301-4B5B-88E7-E5046E8FC5D6}"/>
+                <a16:creationId xmlns:a16="http://schemas.microsoft.com/office/drawing/2014/main" id="{019376E8-791D-407D-A9DA-0D1A34370C08}"/>
               </a:ext>
             </a:extLst>
           </p:cNvPr>
@@ -6194,7 +6200,7 @@
     </p:spTree>
     <p:extLst>
       <p:ext uri="{BB962C8B-B14F-4D97-AF65-F5344CB8AC3E}">
-        <p14:creationId xmlns:p14="http://schemas.microsoft.com/office/powerpoint/2010/main" val="402333503"/>
+        <p14:creationId xmlns:p14="http://schemas.microsoft.com/office/powerpoint/2010/main" val="1618507941"/>
       </p:ext>
     </p:extLst>
   </p:cSld>
@@ -6225,7 +6231,7 @@
           <p:cNvPr id="6" name="title-8">
             <a:extLst xmlns:a="http://schemas.openxmlformats.org/drawingml/2006/main">
               <a:ext uri="{FF2B5EF4-FFF2-40B4-BE49-F238E27FC236}">
-                <a16:creationId xmlns:a16="http://schemas.microsoft.com/office/drawing/2014/main" id="{2B6BCC71-9F8D-4BC4-8DDB-85C264E64B78}"/>
+                <a16:creationId xmlns:a16="http://schemas.microsoft.com/office/drawing/2014/main" id="{B9E647F3-9F08-4846-B25E-6AE751423998}"/>
               </a:ext>
             </a:extLst>
           </p:cNvPr>
@@ -6272,7 +6278,7 @@
                 <a:ea typeface="Arial"/>
                 <a:cs typeface="Arial"/>
               </a:rPr>
-              <a:t>Nouveau run : cinq choix à vérifier</a:t>
+              <a:t>Avant Launch : cinq choix à vérifier</a:t>
             </a:r>
           </a:p>
         </p:txBody>
@@ -6282,7 +6288,7 @@
           <p:cNvPr id="2" name="page-8">
             <a:extLst xmlns:a="http://schemas.openxmlformats.org/drawingml/2006/main">
               <a:ext uri="{FF2B5EF4-FFF2-40B4-BE49-F238E27FC236}">
-                <a16:creationId xmlns:a16="http://schemas.microsoft.com/office/drawing/2014/main" id="{DA8AFEA5-E8C0-4B94-8890-13B93B0526A0}"/>
+                <a16:creationId xmlns:a16="http://schemas.microsoft.com/office/drawing/2014/main" id="{8EEA2D29-A7F8-4424-A219-F82E86BCF8F1}"/>
               </a:ext>
             </a:extLst>
           </p:cNvPr>
@@ -6339,7 +6345,7 @@
           <p:cNvPr id="3" name="run-choices">
             <a:extLst xmlns:a="http://schemas.openxmlformats.org/drawingml/2006/main">
               <a:ext uri="{FF2B5EF4-FFF2-40B4-BE49-F238E27FC236}">
-                <a16:creationId xmlns:a16="http://schemas.microsoft.com/office/drawing/2014/main" id="{64CE8956-C581-46E8-A6DA-20F65D75E832}"/>
+                <a16:creationId xmlns:a16="http://schemas.microsoft.com/office/drawing/2014/main" id="{7D95E6EC-A2E0-44AC-AADB-76CC97C4B2A1}"/>
               </a:ext>
             </a:extLst>
           </p:cNvPr>
@@ -6455,7 +6461,7 @@
                 <a:ea typeface="Arial"/>
                 <a:cs typeface="Arial"/>
               </a:rPr>
-              <a:t>4  Agent Claude configuré</a:t>
+              <a:t>4  Agent Claude Code configuré</a:t>
             </a:r>
           </a:p>
           <a:p xmlns:a="http://schemas.openxmlformats.org/drawingml/2006/main">
@@ -6492,7 +6498,7 @@
           <p:nvPr/>
         </p:nvPicPr>
         <p:blipFill>
-          <a:blip xmlns:r="http://schemas.openxmlformats.org/officeDocument/2006/relationships" xmlns:a="http://schemas.openxmlformats.org/drawingml/2006/main" r:embed="R1d142b3d180c42e1"/>
+          <a:blip xmlns:r="http://schemas.openxmlformats.org/officeDocument/2006/relationships" xmlns:a="http://schemas.openxmlformats.org/drawingml/2006/main" r:embed="Rc0d2bcfe5be64e37"/>
           <a:stretch xmlns:a="http://schemas.openxmlformats.org/drawingml/2006/main"/>
         </p:blipFill>
         <p:spPr>
@@ -6510,7 +6516,7 @@
           <p:cNvPr id="5" name="run-not-link">
             <a:extLst xmlns:a="http://schemas.openxmlformats.org/drawingml/2006/main">
               <a:ext uri="{FF2B5EF4-FFF2-40B4-BE49-F238E27FC236}">
-                <a16:creationId xmlns:a16="http://schemas.microsoft.com/office/drawing/2014/main" id="{6236C464-6562-4B62-9C8E-4C2223594C91}"/>
+                <a16:creationId xmlns:a16="http://schemas.microsoft.com/office/drawing/2014/main" id="{5E577C77-5807-4F6B-91AE-0436C54E8F96}"/>
               </a:ext>
             </a:extLst>
           </p:cNvPr>
@@ -6565,7 +6571,7 @@
     </p:spTree>
     <p:extLst>
       <p:ext uri="{BB962C8B-B14F-4D97-AF65-F5344CB8AC3E}">
-        <p14:creationId xmlns:p14="http://schemas.microsoft.com/office/powerpoint/2010/main" val="608613532"/>
+        <p14:creationId xmlns:p14="http://schemas.microsoft.com/office/powerpoint/2010/main" val="20601137"/>
       </p:ext>
     </p:extLst>
   </p:cSld>
@@ -6596,7 +6602,7 @@
           <p:cNvPr id="7" name="title-9">
             <a:extLst xmlns:a="http://schemas.openxmlformats.org/drawingml/2006/main">
               <a:ext uri="{FF2B5EF4-FFF2-40B4-BE49-F238E27FC236}">
-                <a16:creationId xmlns:a16="http://schemas.microsoft.com/office/drawing/2014/main" id="{358B8F77-F6D6-4A3A-972E-C31C665163BC}"/>
+                <a16:creationId xmlns:a16="http://schemas.microsoft.com/office/drawing/2014/main" id="{3555928E-7766-4E56-8FC1-6C284F335B61}"/>
               </a:ext>
             </a:extLst>
           </p:cNvPr>
@@ -6653,7 +6659,7 @@
           <p:cNvPr id="2" name="page-9">
             <a:extLst xmlns:a="http://schemas.openxmlformats.org/drawingml/2006/main">
               <a:ext uri="{FF2B5EF4-FFF2-40B4-BE49-F238E27FC236}">
-                <a16:creationId xmlns:a16="http://schemas.microsoft.com/office/drawing/2014/main" id="{C155A526-661A-4CC2-A1FD-623815625F9B}"/>
+                <a16:creationId xmlns:a16="http://schemas.microsoft.com/office/drawing/2014/main" id="{59954C6B-2C15-4F47-A709-8E28701B3468}"/>
               </a:ext>
             </a:extLst>
           </p:cNvPr>
@@ -6710,7 +6716,7 @@
           <p:cNvPr id="3" name="live-launch">
             <a:extLst xmlns:a="http://schemas.openxmlformats.org/drawingml/2006/main">
               <a:ext uri="{FF2B5EF4-FFF2-40B4-BE49-F238E27FC236}">
-                <a16:creationId xmlns:a16="http://schemas.microsoft.com/office/drawing/2014/main" id="{C37ACC01-8927-4AC7-B4F2-2F12E2DCE349}"/>
+                <a16:creationId xmlns:a16="http://schemas.microsoft.com/office/drawing/2014/main" id="{61F0E02F-E079-4A5E-B194-9C82776B4B41}"/>
               </a:ext>
             </a:extLst>
           </p:cNvPr>
@@ -6767,7 +6773,7 @@
           <p:cNvPr id="4" name="live-id">
             <a:extLst xmlns:a="http://schemas.openxmlformats.org/drawingml/2006/main">
               <a:ext uri="{FF2B5EF4-FFF2-40B4-BE49-F238E27FC236}">
-                <a16:creationId xmlns:a16="http://schemas.microsoft.com/office/drawing/2014/main" id="{7DB255EE-4A32-4E01-B0CA-A3C6B39073C3}"/>
+                <a16:creationId xmlns:a16="http://schemas.microsoft.com/office/drawing/2014/main" id="{0D5C6E9C-9EFB-410A-BFBC-E4C9A02A0984}"/>
               </a:ext>
             </a:extLst>
           </p:cNvPr>
@@ -6824,7 +6830,7 @@
           <p:cNvPr id="5" name="prepared-label">
             <a:extLst xmlns:a="http://schemas.openxmlformats.org/drawingml/2006/main">
               <a:ext uri="{FF2B5EF4-FFF2-40B4-BE49-F238E27FC236}">
-                <a16:creationId xmlns:a16="http://schemas.microsoft.com/office/drawing/2014/main" id="{6C763DDA-105F-4A49-A126-3FFBD66FE65C}"/>
+                <a16:creationId xmlns:a16="http://schemas.microsoft.com/office/drawing/2014/main" id="{F6181420-2CEF-498C-94D2-44C927C5F3D5}"/>
               </a:ext>
             </a:extLst>
           </p:cNvPr>
@@ -6881,7 +6887,7 @@
           <p:cNvPr id="6" name="prepared-id">
             <a:extLst xmlns:a="http://schemas.openxmlformats.org/drawingml/2006/main">
               <a:ext uri="{FF2B5EF4-FFF2-40B4-BE49-F238E27FC236}">
-                <a16:creationId xmlns:a16="http://schemas.microsoft.com/office/drawing/2014/main" id="{0360A372-8AF6-4D70-ABD9-3F2D13C1D8F0}"/>
+                <a16:creationId xmlns:a16="http://schemas.microsoft.com/office/drawing/2014/main" id="{8FB388A1-A71B-4BDD-B01C-EF601D868ECC}"/>
               </a:ext>
             </a:extLst>
           </p:cNvPr>
@@ -6912,7 +6918,7 @@
             <a:pPr algn="l">
               <a:defRPr sz="1950" b="0">
                 <a:solidFill>
-                  <a:srgbClr val="8BE0C9"/>
+                  <a:srgbClr val="E9A93C"/>
                 </a:solidFill>
                 <a:latin typeface="Arial"/>
                 <a:ea typeface="Arial"/>
@@ -6922,12 +6928,12 @@
             <a:r>
               <a:rPr sz="1950" b="0">
                 <a:solidFill>
-                  <a:srgbClr val="8BE0C9"/>
-                </a:solidFill>
-                <a:latin typeface="Arial"/>
-                <a:ea typeface="Arial"/>
-                <a:cs typeface="Arial"/>
-                <a:hlinkClick xmlns:r="http://schemas.openxmlformats.org/officeDocument/2006/relationships" r:id="R262d6b23062848ee"/>
+                  <a:srgbClr val="E9A93C"/>
+                </a:solidFill>
+                <a:latin typeface="Arial"/>
+                <a:ea typeface="Arial"/>
+                <a:cs typeface="Arial"/>
+                <a:hlinkClick xmlns:r="http://schemas.openxmlformats.org/officeDocument/2006/relationships" r:id="R09de163c843948ba"/>
               </a:rPr>
               <a:t>20261001-183530-abd2d8d</a:t>
             </a:r>
@@ -6937,7 +6943,7 @@
     </p:spTree>
     <p:extLst>
       <p:ext uri="{BB962C8B-B14F-4D97-AF65-F5344CB8AC3E}">
-        <p14:creationId xmlns:p14="http://schemas.microsoft.com/office/powerpoint/2010/main" val="1643423395"/>
+        <p14:creationId xmlns:p14="http://schemas.microsoft.com/office/powerpoint/2010/main" val="1632263935"/>
       </p:ext>
     </p:extLst>
   </p:cSld>

</xml_diff>